<commit_message>
fix: preserve challenge prose formatting
</commit_message>
<xml_diff>
--- a/Mapped Curriculum Lessons/Grade 6/Lesson 01 - Hello Python!/Hello Python! - Slides.pptx
+++ b/Mapped Curriculum Lessons/Grade 6/Lesson 01 - Hello Python!/Hello Python! - Slides.pptx
@@ -2,28 +2,28 @@
 <file path=ppt/presentation.xml><?xml version="1.0" encoding="utf-8"?>
 <p:presentation xmlns:p="http://schemas.openxmlformats.org/presentationml/2006/main" embedTrueTypeFonts="1" saveSubsetFonts="0">
   <p:sldMasterIdLst>
-    <p:sldMasterId xmlns:r="http://schemas.openxmlformats.org/officeDocument/2006/relationships" id="2147483648" r:id="Rf8411234d4404e58"/>
+    <p:sldMasterId xmlns:r="http://schemas.openxmlformats.org/officeDocument/2006/relationships" id="2147483648" r:id="R5b3ab1f37f7b4fd4"/>
   </p:sldMasterIdLst>
   <p:notesMasterIdLst>
-    <p:notesMasterId xmlns:r="http://schemas.openxmlformats.org/officeDocument/2006/relationships" r:id="Re0c81fd5174646de"/>
+    <p:notesMasterId xmlns:r="http://schemas.openxmlformats.org/officeDocument/2006/relationships" r:id="R2c8e034217dd407a"/>
   </p:notesMasterIdLst>
   <p:sldIdLst>
-    <p:sldId xmlns:r="http://schemas.openxmlformats.org/officeDocument/2006/relationships" id="256" r:id="Re01d7a3a15b44d24"/>
-    <p:sldId xmlns:r="http://schemas.openxmlformats.org/officeDocument/2006/relationships" id="257" r:id="R75f8e32bcff24708"/>
-    <p:sldId xmlns:r="http://schemas.openxmlformats.org/officeDocument/2006/relationships" id="258" r:id="Rad3fae8697924d41"/>
-    <p:sldId xmlns:r="http://schemas.openxmlformats.org/officeDocument/2006/relationships" id="259" r:id="Rf240470483c7471a"/>
-    <p:sldId xmlns:r="http://schemas.openxmlformats.org/officeDocument/2006/relationships" id="260" r:id="R455faf86226345df"/>
-    <p:sldId xmlns:r="http://schemas.openxmlformats.org/officeDocument/2006/relationships" id="261" r:id="R1c060b547142481a"/>
-    <p:sldId xmlns:r="http://schemas.openxmlformats.org/officeDocument/2006/relationships" id="262" r:id="R0a49d007d24d4ec6"/>
-    <p:sldId xmlns:r="http://schemas.openxmlformats.org/officeDocument/2006/relationships" id="263" r:id="Rafc9bc4b7c6948ad"/>
-    <p:sldId xmlns:r="http://schemas.openxmlformats.org/officeDocument/2006/relationships" id="264" r:id="R38bd068472504896"/>
+    <p:sldId xmlns:r="http://schemas.openxmlformats.org/officeDocument/2006/relationships" id="256" r:id="R5006481181f74972"/>
+    <p:sldId xmlns:r="http://schemas.openxmlformats.org/officeDocument/2006/relationships" id="257" r:id="Rfc540f9b86654e2b"/>
+    <p:sldId xmlns:r="http://schemas.openxmlformats.org/officeDocument/2006/relationships" id="258" r:id="Ra7a38ec2467d4ca9"/>
+    <p:sldId xmlns:r="http://schemas.openxmlformats.org/officeDocument/2006/relationships" id="259" r:id="Rdf4a06c9b30140f8"/>
+    <p:sldId xmlns:r="http://schemas.openxmlformats.org/officeDocument/2006/relationships" id="260" r:id="Rf1ce9f38799548ce"/>
+    <p:sldId xmlns:r="http://schemas.openxmlformats.org/officeDocument/2006/relationships" id="261" r:id="Rbffa48ca563c484b"/>
+    <p:sldId xmlns:r="http://schemas.openxmlformats.org/officeDocument/2006/relationships" id="262" r:id="R63ae1fb120fd4146"/>
+    <p:sldId xmlns:r="http://schemas.openxmlformats.org/officeDocument/2006/relationships" id="263" r:id="R7a4a6b1f1bd640eb"/>
+    <p:sldId xmlns:r="http://schemas.openxmlformats.org/officeDocument/2006/relationships" id="264" r:id="R98c60a8f05aa4d12"/>
   </p:sldIdLst>
   <p:sldSz cx="12192000" cy="6858000"/>
   <p:notesSz cx="6858000" cy="9144000"/>
   <p:embeddedFontLst>
     <p:embeddedFont>
       <p:font typeface="JetBrains Mono"/>
-      <p:regular xmlns:r="http://schemas.openxmlformats.org/officeDocument/2006/relationships" r:id="R3fcfe2de975d4e12"/>
+      <p:regular xmlns:r="http://schemas.openxmlformats.org/officeDocument/2006/relationships" r:id="R8d202732b2114bcf"/>
     </p:embeddedFont>
   </p:embeddedFontLst>
 </p:presentation>
@@ -1071,7 +1071,7 @@
           <p:nvPr/>
         </p:nvPicPr>
         <p:blipFill rotWithShape="1">
-          <a:blip xmlns:r="http://schemas.openxmlformats.org/officeDocument/2006/relationships" xmlns:a="http://schemas.openxmlformats.org/drawingml/2006/main" r:embed="Rb60127037b674811"/>
+          <a:blip xmlns:r="http://schemas.openxmlformats.org/officeDocument/2006/relationships" xmlns:a="http://schemas.openxmlformats.org/drawingml/2006/main" r:embed="Rb3653904707144b0"/>
           <a:stretch xmlns:a="http://schemas.openxmlformats.org/drawingml/2006/main"/>
         </p:blipFill>
         <p:spPr>
@@ -1451,7 +1451,7 @@
           <p:nvPr/>
         </p:nvPicPr>
         <p:blipFill rotWithShape="1">
-          <a:blip xmlns:r="http://schemas.openxmlformats.org/officeDocument/2006/relationships" xmlns:a="http://schemas.openxmlformats.org/drawingml/2006/main" r:embed="Ra0148fca14c04851">
+          <a:blip xmlns:r="http://schemas.openxmlformats.org/officeDocument/2006/relationships" xmlns:a="http://schemas.openxmlformats.org/drawingml/2006/main" r:embed="R4eb85485c7834233">
             <a:alphaModFix amt="28000"/>
           </a:blip>
           <a:stretch xmlns:a="http://schemas.openxmlformats.org/drawingml/2006/main"/>
@@ -1664,7 +1664,7 @@
           <p:nvPr/>
         </p:nvPicPr>
         <p:blipFill rotWithShape="1">
-          <a:blip xmlns:r="http://schemas.openxmlformats.org/officeDocument/2006/relationships" xmlns:a="http://schemas.openxmlformats.org/drawingml/2006/main" r:embed="Rf9f02e37a25d438f">
+          <a:blip xmlns:r="http://schemas.openxmlformats.org/officeDocument/2006/relationships" xmlns:a="http://schemas.openxmlformats.org/drawingml/2006/main" r:embed="Rff5a5d2dc09041c3">
             <a:alphaModFix amt="28000"/>
           </a:blip>
           <a:stretch xmlns:a="http://schemas.openxmlformats.org/drawingml/2006/main"/>
@@ -1899,7 +1899,7 @@
           <p:nvPr/>
         </p:nvPicPr>
         <p:blipFill rotWithShape="1">
-          <a:blip xmlns:r="http://schemas.openxmlformats.org/officeDocument/2006/relationships" xmlns:a="http://schemas.openxmlformats.org/drawingml/2006/main" r:embed="R02608f759ab4423a">
+          <a:blip xmlns:r="http://schemas.openxmlformats.org/officeDocument/2006/relationships" xmlns:a="http://schemas.openxmlformats.org/drawingml/2006/main" r:embed="R55c120c409df4927">
             <a:alphaModFix amt="28000"/>
           </a:blip>
           <a:stretch xmlns:a="http://schemas.openxmlformats.org/drawingml/2006/main"/>
@@ -2176,7 +2176,7 @@
           <p:nvPr/>
         </p:nvPicPr>
         <p:blipFill rotWithShape="1">
-          <a:blip xmlns:r="http://schemas.openxmlformats.org/officeDocument/2006/relationships" xmlns:a="http://schemas.openxmlformats.org/drawingml/2006/main" r:embed="Ra6e76f7c3da742ad">
+          <a:blip xmlns:r="http://schemas.openxmlformats.org/officeDocument/2006/relationships" xmlns:a="http://schemas.openxmlformats.org/drawingml/2006/main" r:embed="R45f2673f446c4cfe">
             <a:alphaModFix amt="28000"/>
           </a:blip>
           <a:stretch xmlns:a="http://schemas.openxmlformats.org/drawingml/2006/main"/>
@@ -2451,7 +2451,7 @@
           <p:nvPr/>
         </p:nvPicPr>
         <p:blipFill rotWithShape="1">
-          <a:blip xmlns:r="http://schemas.openxmlformats.org/officeDocument/2006/relationships" xmlns:a="http://schemas.openxmlformats.org/drawingml/2006/main" r:embed="R570a4d82481b47ff">
+          <a:blip xmlns:r="http://schemas.openxmlformats.org/officeDocument/2006/relationships" xmlns:a="http://schemas.openxmlformats.org/drawingml/2006/main" r:embed="R7947e1b8f2534f4f">
             <a:alphaModFix amt="28000"/>
           </a:blip>
           <a:stretch xmlns:a="http://schemas.openxmlformats.org/drawingml/2006/main"/>
@@ -2875,7 +2875,7 @@
           <p:nvPr/>
         </p:nvPicPr>
         <p:blipFill rotWithShape="1">
-          <a:blip xmlns:r="http://schemas.openxmlformats.org/officeDocument/2006/relationships" xmlns:a="http://schemas.openxmlformats.org/drawingml/2006/main" r:embed="R79ae5ed75a594d9a">
+          <a:blip xmlns:r="http://schemas.openxmlformats.org/officeDocument/2006/relationships" xmlns:a="http://schemas.openxmlformats.org/drawingml/2006/main" r:embed="R8b2fb31e93f24d5d">
             <a:alphaModFix amt="28000"/>
           </a:blip>
           <a:stretch xmlns:a="http://schemas.openxmlformats.org/drawingml/2006/main"/>
@@ -3016,7 +3016,7 @@
           <p:nvPr/>
         </p:nvPicPr>
         <p:blipFill rotWithShape="1">
-          <a:blip xmlns:r="http://schemas.openxmlformats.org/officeDocument/2006/relationships" xmlns:a="http://schemas.openxmlformats.org/drawingml/2006/main" r:embed="R65016dbe33044ca1">
+          <a:blip xmlns:r="http://schemas.openxmlformats.org/officeDocument/2006/relationships" xmlns:a="http://schemas.openxmlformats.org/drawingml/2006/main" r:embed="Ra0bff15202d54d33">
             <a:alphaModFix amt="28000"/>
           </a:blip>
           <a:stretch xmlns:a="http://schemas.openxmlformats.org/drawingml/2006/main"/>
@@ -3130,7 +3130,7 @@
           <p:nvPr/>
         </p:nvPicPr>
         <p:blipFill rotWithShape="1">
-          <a:blip xmlns:r="http://schemas.openxmlformats.org/officeDocument/2006/relationships" xmlns:a="http://schemas.openxmlformats.org/drawingml/2006/main" r:embed="R57ea0ae5c1da4e53">
+          <a:blip xmlns:r="http://schemas.openxmlformats.org/officeDocument/2006/relationships" xmlns:a="http://schemas.openxmlformats.org/drawingml/2006/main" r:embed="Re6c879d89ac54143">
             <a:alphaModFix amt="28000"/>
           </a:blip>
           <a:stretch xmlns:a="http://schemas.openxmlformats.org/drawingml/2006/main"/>
@@ -3457,7 +3457,7 @@
           <p:nvPr/>
         </p:nvPicPr>
         <p:blipFill rotWithShape="1">
-          <a:blip xmlns:r="http://schemas.openxmlformats.org/officeDocument/2006/relationships" xmlns:a="http://schemas.openxmlformats.org/drawingml/2006/main" r:embed="R03ab288fc976410e">
+          <a:blip xmlns:r="http://schemas.openxmlformats.org/officeDocument/2006/relationships" xmlns:a="http://schemas.openxmlformats.org/drawingml/2006/main" r:embed="Rd9ff59af3dd24009">
             <a:alphaModFix amt="28000"/>
           </a:blip>
           <a:stretch xmlns:a="http://schemas.openxmlformats.org/drawingml/2006/main"/>
@@ -3745,7 +3745,7 @@
           <p:nvPr/>
         </p:nvPicPr>
         <p:blipFill rotWithShape="1">
-          <a:blip xmlns:r="http://schemas.openxmlformats.org/officeDocument/2006/relationships" xmlns:a="http://schemas.openxmlformats.org/drawingml/2006/main" r:embed="Rea5d6df4111c402d">
+          <a:blip xmlns:r="http://schemas.openxmlformats.org/officeDocument/2006/relationships" xmlns:a="http://schemas.openxmlformats.org/drawingml/2006/main" r:embed="R68a1ffc646ca428d">
             <a:alphaModFix amt="28000"/>
           </a:blip>
           <a:stretch xmlns:a="http://schemas.openxmlformats.org/drawingml/2006/main"/>
@@ -3982,17 +3982,17 @@
   </p:cSld>
   <p:clrMap bg1="lt1" tx1="dk1" bg2="lt2" tx2="dk2" accent1="accent1" accent2="accent2" accent3="accent3" accent4="accent4" accent5="accent5" accent6="accent6" hlink="hlink" folHlink="folHlink"/>
   <p:sldLayoutIdLst>
-    <p:sldLayoutId xmlns:r="http://schemas.openxmlformats.org/officeDocument/2006/relationships" id="2147483649" r:id="R296be400ae2f4eb1"/>
-    <p:sldLayoutId xmlns:r="http://schemas.openxmlformats.org/officeDocument/2006/relationships" id="2147483650" r:id="R8440f8422e2b47f3"/>
-    <p:sldLayoutId xmlns:r="http://schemas.openxmlformats.org/officeDocument/2006/relationships" id="2147483651" r:id="Recdb55a7ba594179"/>
-    <p:sldLayoutId xmlns:r="http://schemas.openxmlformats.org/officeDocument/2006/relationships" id="2147483652" r:id="R5a7f4895e36848f7"/>
-    <p:sldLayoutId xmlns:r="http://schemas.openxmlformats.org/officeDocument/2006/relationships" id="2147483653" r:id="R7ce506187b2d472a"/>
-    <p:sldLayoutId xmlns:r="http://schemas.openxmlformats.org/officeDocument/2006/relationships" id="2147483654" r:id="R6213553e5e5842da"/>
-    <p:sldLayoutId xmlns:r="http://schemas.openxmlformats.org/officeDocument/2006/relationships" id="2147483655" r:id="R63c3692e277a418a"/>
-    <p:sldLayoutId xmlns:r="http://schemas.openxmlformats.org/officeDocument/2006/relationships" id="2147483656" r:id="Rddf2ab99e0a44936"/>
-    <p:sldLayoutId xmlns:r="http://schemas.openxmlformats.org/officeDocument/2006/relationships" id="2147483657" r:id="R501f4223e93c46b9"/>
-    <p:sldLayoutId xmlns:r="http://schemas.openxmlformats.org/officeDocument/2006/relationships" id="2147483658" r:id="R0cbc392625954ea6"/>
-    <p:sldLayoutId xmlns:r="http://schemas.openxmlformats.org/officeDocument/2006/relationships" id="2147483659" r:id="R2684da70cb714bfc"/>
+    <p:sldLayoutId xmlns:r="http://schemas.openxmlformats.org/officeDocument/2006/relationships" id="2147483649" r:id="Rbb0349c380ea422c"/>
+    <p:sldLayoutId xmlns:r="http://schemas.openxmlformats.org/officeDocument/2006/relationships" id="2147483650" r:id="R210120cf40e14976"/>
+    <p:sldLayoutId xmlns:r="http://schemas.openxmlformats.org/officeDocument/2006/relationships" id="2147483651" r:id="R848aefa1b2254982"/>
+    <p:sldLayoutId xmlns:r="http://schemas.openxmlformats.org/officeDocument/2006/relationships" id="2147483652" r:id="R5757c4c2b02a462f"/>
+    <p:sldLayoutId xmlns:r="http://schemas.openxmlformats.org/officeDocument/2006/relationships" id="2147483653" r:id="R0c2ca966c43b42f0"/>
+    <p:sldLayoutId xmlns:r="http://schemas.openxmlformats.org/officeDocument/2006/relationships" id="2147483654" r:id="R0302a8045d2d42bb"/>
+    <p:sldLayoutId xmlns:r="http://schemas.openxmlformats.org/officeDocument/2006/relationships" id="2147483655" r:id="Rc12177b237094954"/>
+    <p:sldLayoutId xmlns:r="http://schemas.openxmlformats.org/officeDocument/2006/relationships" id="2147483656" r:id="R00f5388e04be4800"/>
+    <p:sldLayoutId xmlns:r="http://schemas.openxmlformats.org/officeDocument/2006/relationships" id="2147483657" r:id="R49a16a0f3d66402b"/>
+    <p:sldLayoutId xmlns:r="http://schemas.openxmlformats.org/officeDocument/2006/relationships" id="2147483658" r:id="R17a59e319c6e47b6"/>
+    <p:sldLayoutId xmlns:r="http://schemas.openxmlformats.org/officeDocument/2006/relationships" id="2147483659" r:id="Rd722659619614c8c"/>
   </p:sldLayoutIdLst>
   <p:hf hdr="0" ftr="0" dt="0"/>
   <p:txStyles>
@@ -7248,18 +7248,18 @@
                 <a:ea typeface="Calibri"/>
                 <a:cs typeface="Calibri"/>
               </a:rPr>
-              <a:t>Ask for a friend's name </a:t>
+              <a:t>Ask for a friend's name and store it in a variable called [friend_name]. Change </a:t>
             </a:r>
             <a:r>
               <a:rPr sz="2400" b="0">
                 <a:solidFill>
-                  <a:srgbClr val="067D17"/>
-                </a:solidFill>
-                <a:latin typeface="JetBrains Mono"/>
-                <a:ea typeface="JetBrains Mono"/>
-                <a:cs typeface="JetBrains Mono"/>
-              </a:rPr>
-              <a:t>"and"</a:t>
+                  <a:srgbClr val="1750EB"/>
+                </a:solidFill>
+                <a:latin typeface="JetBrains Mono"/>
+                <a:ea typeface="JetBrains Mono"/>
+                <a:cs typeface="JetBrains Mono"/>
+              </a:rPr>
+              <a:t>print()</a:t>
             </a:r>
             <a:r>
               <a:rPr sz="2400" b="0">
@@ -7270,18 +7270,18 @@
                 <a:ea typeface="Calibri"/>
                 <a:cs typeface="Calibri"/>
               </a:rPr>
-              <a:t> store it in a variable called [friend_name]. Change </a:t>
+              <a:t> so it displays </a:t>
             </a:r>
             <a:r>
               <a:rPr sz="2400" b="0">
                 <a:solidFill>
-                  <a:srgbClr val="1750EB"/>
-                </a:solidFill>
-                <a:latin typeface="JetBrains Mono"/>
-                <a:ea typeface="JetBrains Mono"/>
-                <a:cs typeface="JetBrains Mono"/>
-              </a:rPr>
-              <a:t>print()</a:t>
+                  <a:srgbClr val="067D17"/>
+                </a:solidFill>
+                <a:latin typeface="JetBrains Mono"/>
+                <a:ea typeface="JetBrains Mono"/>
+                <a:cs typeface="JetBrains Mono"/>
+              </a:rPr>
+              <a:t>"Hello, [name] and [friend_name]!"</a:t>
             </a:r>
             <a:r>
               <a:rPr sz="2400" b="0">
@@ -7292,51 +7292,7 @@
                 <a:ea typeface="Calibri"/>
                 <a:cs typeface="Calibri"/>
               </a:rPr>
-              <a:t> so it displays </a:t>
-            </a:r>
-            <a:r>
-              <a:rPr sz="2400" b="0">
-                <a:solidFill>
-                  <a:srgbClr val="067D17"/>
-                </a:solidFill>
-                <a:latin typeface="JetBrains Mono"/>
-                <a:ea typeface="JetBrains Mono"/>
-                <a:cs typeface="JetBrains Mono"/>
-              </a:rPr>
-              <a:t>"Hello, [name] and [friend_name]!"</a:t>
-            </a:r>
-            <a:r>
-              <a:rPr sz="2400" b="0">
-                <a:solidFill>
-                  <a:srgbClr val="080808"/>
-                </a:solidFill>
-                <a:latin typeface="Calibri"/>
-                <a:ea typeface="Calibri"/>
-                <a:cs typeface="Calibri"/>
-              </a:rPr>
-              <a:t> using [name] </a:t>
-            </a:r>
-            <a:r>
-              <a:rPr sz="2400" b="0">
-                <a:solidFill>
-                  <a:srgbClr val="067D17"/>
-                </a:solidFill>
-                <a:latin typeface="JetBrains Mono"/>
-                <a:ea typeface="JetBrains Mono"/>
-                <a:cs typeface="JetBrains Mono"/>
-              </a:rPr>
-              <a:t>"and"</a:t>
-            </a:r>
-            <a:r>
-              <a:rPr sz="2400" b="0">
-                <a:solidFill>
-                  <a:srgbClr val="080808"/>
-                </a:solidFill>
-                <a:latin typeface="Calibri"/>
-                <a:ea typeface="Calibri"/>
-                <a:cs typeface="Calibri"/>
-              </a:rPr>
-              <a:t> [friend_name].</a:t>
+              <a:t> using [name] and [friend_name].</a:t>
             </a:r>
           </a:p>
         </p:txBody>

</xml_diff>

<commit_message>
feat: apply approved challenge review updates
</commit_message>
<xml_diff>
--- a/Mapped Curriculum Lessons/Grade 6/Lesson 01 - Hello Python!/Hello Python! - Slides.pptx
+++ b/Mapped Curriculum Lessons/Grade 6/Lesson 01 - Hello Python!/Hello Python! - Slides.pptx
@@ -2,28 +2,28 @@
 <file path=ppt/presentation.xml><?xml version="1.0" encoding="utf-8"?>
 <p:presentation xmlns:p="http://schemas.openxmlformats.org/presentationml/2006/main" embedTrueTypeFonts="1" saveSubsetFonts="0">
   <p:sldMasterIdLst>
-    <p:sldMasterId xmlns:r="http://schemas.openxmlformats.org/officeDocument/2006/relationships" id="2147483648" r:id="R5b3ab1f37f7b4fd4"/>
+    <p:sldMasterId xmlns:r="http://schemas.openxmlformats.org/officeDocument/2006/relationships" id="2147483648" r:id="Rbd71e6d1134a48d9"/>
   </p:sldMasterIdLst>
   <p:notesMasterIdLst>
-    <p:notesMasterId xmlns:r="http://schemas.openxmlformats.org/officeDocument/2006/relationships" r:id="R2c8e034217dd407a"/>
+    <p:notesMasterId xmlns:r="http://schemas.openxmlformats.org/officeDocument/2006/relationships" r:id="R7d11d8dae7524620"/>
   </p:notesMasterIdLst>
   <p:sldIdLst>
-    <p:sldId xmlns:r="http://schemas.openxmlformats.org/officeDocument/2006/relationships" id="256" r:id="R5006481181f74972"/>
-    <p:sldId xmlns:r="http://schemas.openxmlformats.org/officeDocument/2006/relationships" id="257" r:id="Rfc540f9b86654e2b"/>
-    <p:sldId xmlns:r="http://schemas.openxmlformats.org/officeDocument/2006/relationships" id="258" r:id="Ra7a38ec2467d4ca9"/>
-    <p:sldId xmlns:r="http://schemas.openxmlformats.org/officeDocument/2006/relationships" id="259" r:id="Rdf4a06c9b30140f8"/>
-    <p:sldId xmlns:r="http://schemas.openxmlformats.org/officeDocument/2006/relationships" id="260" r:id="Rf1ce9f38799548ce"/>
-    <p:sldId xmlns:r="http://schemas.openxmlformats.org/officeDocument/2006/relationships" id="261" r:id="Rbffa48ca563c484b"/>
-    <p:sldId xmlns:r="http://schemas.openxmlformats.org/officeDocument/2006/relationships" id="262" r:id="R63ae1fb120fd4146"/>
-    <p:sldId xmlns:r="http://schemas.openxmlformats.org/officeDocument/2006/relationships" id="263" r:id="R7a4a6b1f1bd640eb"/>
-    <p:sldId xmlns:r="http://schemas.openxmlformats.org/officeDocument/2006/relationships" id="264" r:id="R98c60a8f05aa4d12"/>
+    <p:sldId xmlns:r="http://schemas.openxmlformats.org/officeDocument/2006/relationships" id="256" r:id="R70af5a42fa1243fa"/>
+    <p:sldId xmlns:r="http://schemas.openxmlformats.org/officeDocument/2006/relationships" id="257" r:id="Rd97cecedd71c43d3"/>
+    <p:sldId xmlns:r="http://schemas.openxmlformats.org/officeDocument/2006/relationships" id="258" r:id="R07f8cb41e8f04d95"/>
+    <p:sldId xmlns:r="http://schemas.openxmlformats.org/officeDocument/2006/relationships" id="259" r:id="Ra571fae7f0174e5a"/>
+    <p:sldId xmlns:r="http://schemas.openxmlformats.org/officeDocument/2006/relationships" id="260" r:id="R75ecf20f97ae4dcb"/>
+    <p:sldId xmlns:r="http://schemas.openxmlformats.org/officeDocument/2006/relationships" id="261" r:id="R29a150bab71f4990"/>
+    <p:sldId xmlns:r="http://schemas.openxmlformats.org/officeDocument/2006/relationships" id="262" r:id="Rae16e80c9dd54a19"/>
+    <p:sldId xmlns:r="http://schemas.openxmlformats.org/officeDocument/2006/relationships" id="263" r:id="R67f008adf5ec4180"/>
+    <p:sldId xmlns:r="http://schemas.openxmlformats.org/officeDocument/2006/relationships" id="264" r:id="R8c79f23daca54bac"/>
   </p:sldIdLst>
   <p:sldSz cx="12192000" cy="6858000"/>
   <p:notesSz cx="6858000" cy="9144000"/>
   <p:embeddedFontLst>
     <p:embeddedFont>
       <p:font typeface="JetBrains Mono"/>
-      <p:regular xmlns:r="http://schemas.openxmlformats.org/officeDocument/2006/relationships" r:id="R8d202732b2114bcf"/>
+      <p:regular xmlns:r="http://schemas.openxmlformats.org/officeDocument/2006/relationships" r:id="R59a03fbf403c4da7"/>
     </p:embeddedFont>
   </p:embeddedFontLst>
 </p:presentation>
@@ -1071,7 +1071,7 @@
           <p:nvPr/>
         </p:nvPicPr>
         <p:blipFill rotWithShape="1">
-          <a:blip xmlns:r="http://schemas.openxmlformats.org/officeDocument/2006/relationships" xmlns:a="http://schemas.openxmlformats.org/drawingml/2006/main" r:embed="Rb3653904707144b0"/>
+          <a:blip xmlns:r="http://schemas.openxmlformats.org/officeDocument/2006/relationships" xmlns:a="http://schemas.openxmlformats.org/drawingml/2006/main" r:embed="R5b8c24a0e69d47f7"/>
           <a:stretch xmlns:a="http://schemas.openxmlformats.org/drawingml/2006/main"/>
         </p:blipFill>
         <p:spPr>
@@ -1451,7 +1451,7 @@
           <p:nvPr/>
         </p:nvPicPr>
         <p:blipFill rotWithShape="1">
-          <a:blip xmlns:r="http://schemas.openxmlformats.org/officeDocument/2006/relationships" xmlns:a="http://schemas.openxmlformats.org/drawingml/2006/main" r:embed="R4eb85485c7834233">
+          <a:blip xmlns:r="http://schemas.openxmlformats.org/officeDocument/2006/relationships" xmlns:a="http://schemas.openxmlformats.org/drawingml/2006/main" r:embed="Rad97389592574150">
             <a:alphaModFix amt="28000"/>
           </a:blip>
           <a:stretch xmlns:a="http://schemas.openxmlformats.org/drawingml/2006/main"/>
@@ -1664,7 +1664,7 @@
           <p:nvPr/>
         </p:nvPicPr>
         <p:blipFill rotWithShape="1">
-          <a:blip xmlns:r="http://schemas.openxmlformats.org/officeDocument/2006/relationships" xmlns:a="http://schemas.openxmlformats.org/drawingml/2006/main" r:embed="Rff5a5d2dc09041c3">
+          <a:blip xmlns:r="http://schemas.openxmlformats.org/officeDocument/2006/relationships" xmlns:a="http://schemas.openxmlformats.org/drawingml/2006/main" r:embed="R8597543349874cc8">
             <a:alphaModFix amt="28000"/>
           </a:blip>
           <a:stretch xmlns:a="http://schemas.openxmlformats.org/drawingml/2006/main"/>
@@ -1899,7 +1899,7 @@
           <p:nvPr/>
         </p:nvPicPr>
         <p:blipFill rotWithShape="1">
-          <a:blip xmlns:r="http://schemas.openxmlformats.org/officeDocument/2006/relationships" xmlns:a="http://schemas.openxmlformats.org/drawingml/2006/main" r:embed="R55c120c409df4927">
+          <a:blip xmlns:r="http://schemas.openxmlformats.org/officeDocument/2006/relationships" xmlns:a="http://schemas.openxmlformats.org/drawingml/2006/main" r:embed="R544632c0ec8c4055">
             <a:alphaModFix amt="28000"/>
           </a:blip>
           <a:stretch xmlns:a="http://schemas.openxmlformats.org/drawingml/2006/main"/>
@@ -2176,7 +2176,7 @@
           <p:nvPr/>
         </p:nvPicPr>
         <p:blipFill rotWithShape="1">
-          <a:blip xmlns:r="http://schemas.openxmlformats.org/officeDocument/2006/relationships" xmlns:a="http://schemas.openxmlformats.org/drawingml/2006/main" r:embed="R45f2673f446c4cfe">
+          <a:blip xmlns:r="http://schemas.openxmlformats.org/officeDocument/2006/relationships" xmlns:a="http://schemas.openxmlformats.org/drawingml/2006/main" r:embed="R6f9ad4229a2546a9">
             <a:alphaModFix amt="28000"/>
           </a:blip>
           <a:stretch xmlns:a="http://schemas.openxmlformats.org/drawingml/2006/main"/>
@@ -2451,7 +2451,7 @@
           <p:nvPr/>
         </p:nvPicPr>
         <p:blipFill rotWithShape="1">
-          <a:blip xmlns:r="http://schemas.openxmlformats.org/officeDocument/2006/relationships" xmlns:a="http://schemas.openxmlformats.org/drawingml/2006/main" r:embed="R7947e1b8f2534f4f">
+          <a:blip xmlns:r="http://schemas.openxmlformats.org/officeDocument/2006/relationships" xmlns:a="http://schemas.openxmlformats.org/drawingml/2006/main" r:embed="R79f15aa0ed494aab">
             <a:alphaModFix amt="28000"/>
           </a:blip>
           <a:stretch xmlns:a="http://schemas.openxmlformats.org/drawingml/2006/main"/>
@@ -2875,7 +2875,7 @@
           <p:nvPr/>
         </p:nvPicPr>
         <p:blipFill rotWithShape="1">
-          <a:blip xmlns:r="http://schemas.openxmlformats.org/officeDocument/2006/relationships" xmlns:a="http://schemas.openxmlformats.org/drawingml/2006/main" r:embed="R8b2fb31e93f24d5d">
+          <a:blip xmlns:r="http://schemas.openxmlformats.org/officeDocument/2006/relationships" xmlns:a="http://schemas.openxmlformats.org/drawingml/2006/main" r:embed="Rdd1a5cb3129c4bad">
             <a:alphaModFix amt="28000"/>
           </a:blip>
           <a:stretch xmlns:a="http://schemas.openxmlformats.org/drawingml/2006/main"/>
@@ -3016,7 +3016,7 @@
           <p:nvPr/>
         </p:nvPicPr>
         <p:blipFill rotWithShape="1">
-          <a:blip xmlns:r="http://schemas.openxmlformats.org/officeDocument/2006/relationships" xmlns:a="http://schemas.openxmlformats.org/drawingml/2006/main" r:embed="Ra0bff15202d54d33">
+          <a:blip xmlns:r="http://schemas.openxmlformats.org/officeDocument/2006/relationships" xmlns:a="http://schemas.openxmlformats.org/drawingml/2006/main" r:embed="Rd06a8e7c89f64807">
             <a:alphaModFix amt="28000"/>
           </a:blip>
           <a:stretch xmlns:a="http://schemas.openxmlformats.org/drawingml/2006/main"/>
@@ -3130,7 +3130,7 @@
           <p:nvPr/>
         </p:nvPicPr>
         <p:blipFill rotWithShape="1">
-          <a:blip xmlns:r="http://schemas.openxmlformats.org/officeDocument/2006/relationships" xmlns:a="http://schemas.openxmlformats.org/drawingml/2006/main" r:embed="Re6c879d89ac54143">
+          <a:blip xmlns:r="http://schemas.openxmlformats.org/officeDocument/2006/relationships" xmlns:a="http://schemas.openxmlformats.org/drawingml/2006/main" r:embed="R2ea275f0dd9a43d5">
             <a:alphaModFix amt="28000"/>
           </a:blip>
           <a:stretch xmlns:a="http://schemas.openxmlformats.org/drawingml/2006/main"/>
@@ -3457,7 +3457,7 @@
           <p:nvPr/>
         </p:nvPicPr>
         <p:blipFill rotWithShape="1">
-          <a:blip xmlns:r="http://schemas.openxmlformats.org/officeDocument/2006/relationships" xmlns:a="http://schemas.openxmlformats.org/drawingml/2006/main" r:embed="Rd9ff59af3dd24009">
+          <a:blip xmlns:r="http://schemas.openxmlformats.org/officeDocument/2006/relationships" xmlns:a="http://schemas.openxmlformats.org/drawingml/2006/main" r:embed="Raa392964982e4be8">
             <a:alphaModFix amt="28000"/>
           </a:blip>
           <a:stretch xmlns:a="http://schemas.openxmlformats.org/drawingml/2006/main"/>
@@ -3745,7 +3745,7 @@
           <p:nvPr/>
         </p:nvPicPr>
         <p:blipFill rotWithShape="1">
-          <a:blip xmlns:r="http://schemas.openxmlformats.org/officeDocument/2006/relationships" xmlns:a="http://schemas.openxmlformats.org/drawingml/2006/main" r:embed="R68a1ffc646ca428d">
+          <a:blip xmlns:r="http://schemas.openxmlformats.org/officeDocument/2006/relationships" xmlns:a="http://schemas.openxmlformats.org/drawingml/2006/main" r:embed="R3bab0e99a4234b73">
             <a:alphaModFix amt="28000"/>
           </a:blip>
           <a:stretch xmlns:a="http://schemas.openxmlformats.org/drawingml/2006/main"/>
@@ -3982,17 +3982,17 @@
   </p:cSld>
   <p:clrMap bg1="lt1" tx1="dk1" bg2="lt2" tx2="dk2" accent1="accent1" accent2="accent2" accent3="accent3" accent4="accent4" accent5="accent5" accent6="accent6" hlink="hlink" folHlink="folHlink"/>
   <p:sldLayoutIdLst>
-    <p:sldLayoutId xmlns:r="http://schemas.openxmlformats.org/officeDocument/2006/relationships" id="2147483649" r:id="Rbb0349c380ea422c"/>
-    <p:sldLayoutId xmlns:r="http://schemas.openxmlformats.org/officeDocument/2006/relationships" id="2147483650" r:id="R210120cf40e14976"/>
-    <p:sldLayoutId xmlns:r="http://schemas.openxmlformats.org/officeDocument/2006/relationships" id="2147483651" r:id="R848aefa1b2254982"/>
-    <p:sldLayoutId xmlns:r="http://schemas.openxmlformats.org/officeDocument/2006/relationships" id="2147483652" r:id="R5757c4c2b02a462f"/>
-    <p:sldLayoutId xmlns:r="http://schemas.openxmlformats.org/officeDocument/2006/relationships" id="2147483653" r:id="R0c2ca966c43b42f0"/>
-    <p:sldLayoutId xmlns:r="http://schemas.openxmlformats.org/officeDocument/2006/relationships" id="2147483654" r:id="R0302a8045d2d42bb"/>
-    <p:sldLayoutId xmlns:r="http://schemas.openxmlformats.org/officeDocument/2006/relationships" id="2147483655" r:id="Rc12177b237094954"/>
-    <p:sldLayoutId xmlns:r="http://schemas.openxmlformats.org/officeDocument/2006/relationships" id="2147483656" r:id="R00f5388e04be4800"/>
-    <p:sldLayoutId xmlns:r="http://schemas.openxmlformats.org/officeDocument/2006/relationships" id="2147483657" r:id="R49a16a0f3d66402b"/>
-    <p:sldLayoutId xmlns:r="http://schemas.openxmlformats.org/officeDocument/2006/relationships" id="2147483658" r:id="R17a59e319c6e47b6"/>
-    <p:sldLayoutId xmlns:r="http://schemas.openxmlformats.org/officeDocument/2006/relationships" id="2147483659" r:id="Rd722659619614c8c"/>
+    <p:sldLayoutId xmlns:r="http://schemas.openxmlformats.org/officeDocument/2006/relationships" id="2147483649" r:id="Rbe63e112a636429a"/>
+    <p:sldLayoutId xmlns:r="http://schemas.openxmlformats.org/officeDocument/2006/relationships" id="2147483650" r:id="Rb563408283d740f1"/>
+    <p:sldLayoutId xmlns:r="http://schemas.openxmlformats.org/officeDocument/2006/relationships" id="2147483651" r:id="R3d7b43fca9bd449b"/>
+    <p:sldLayoutId xmlns:r="http://schemas.openxmlformats.org/officeDocument/2006/relationships" id="2147483652" r:id="Rb9bf26fb22f34e12"/>
+    <p:sldLayoutId xmlns:r="http://schemas.openxmlformats.org/officeDocument/2006/relationships" id="2147483653" r:id="Rfabb5a42d8694056"/>
+    <p:sldLayoutId xmlns:r="http://schemas.openxmlformats.org/officeDocument/2006/relationships" id="2147483654" r:id="Rfc482e378d0d47b0"/>
+    <p:sldLayoutId xmlns:r="http://schemas.openxmlformats.org/officeDocument/2006/relationships" id="2147483655" r:id="R7098ad8e43c44af8"/>
+    <p:sldLayoutId xmlns:r="http://schemas.openxmlformats.org/officeDocument/2006/relationships" id="2147483656" r:id="Rb71baf6a369f447d"/>
+    <p:sldLayoutId xmlns:r="http://schemas.openxmlformats.org/officeDocument/2006/relationships" id="2147483657" r:id="Rfc8dddcd98e74230"/>
+    <p:sldLayoutId xmlns:r="http://schemas.openxmlformats.org/officeDocument/2006/relationships" id="2147483658" r:id="Rf18ee895bdcd47d1"/>
+    <p:sldLayoutId xmlns:r="http://schemas.openxmlformats.org/officeDocument/2006/relationships" id="2147483659" r:id="R0b257a785972475c"/>
   </p:sldLayoutIdLst>
   <p:hf hdr="0" ftr="0" dt="0"/>
   <p:txStyles>

</xml_diff>

<commit_message>
feat: refresh challenge language and compile capstones
Rewrite all 99 compiled challenge prompts toward the target Python
Challenges style: task-first openers, one worked example, no test
scripts. Replace C1/C2 tasks that needed no real code change, resize
Make tasks, fix concept-budget breaches, and update 48 solutions.

Render [variable] markers as plum chips on a tinted background in
worksheets, PDFs and slides, including inside quoted output text.
Set inline code at 85% of body size so it matches Calibri, style
True/False/None, and use embedded JetBrains Mono for prose code.

Build the three capstones (L11, L27, L36) from curriculum/capstones.json
with worksheet styling, filled slide decks and checked solutions, and
verify them alongside the regular suite.

Co-Authored-By: Claude Opus 5.5 <noreply@anthropic.com>
</commit_message>
<xml_diff>
--- a/Mapped Curriculum Lessons/Grade 6/Lesson 01 - Hello Python!/Hello Python! - Slides.pptx
+++ b/Mapped Curriculum Lessons/Grade 6/Lesson 01 - Hello Python!/Hello Python! - Slides.pptx
@@ -2,28 +2,28 @@
 <file path=ppt/presentation.xml><?xml version="1.0" encoding="utf-8"?>
 <p:presentation xmlns:p="http://schemas.openxmlformats.org/presentationml/2006/main" embedTrueTypeFonts="1" saveSubsetFonts="0">
   <p:sldMasterIdLst>
-    <p:sldMasterId xmlns:r="http://schemas.openxmlformats.org/officeDocument/2006/relationships" id="2147483648" r:id="Rbd71e6d1134a48d9"/>
+    <p:sldMasterId xmlns:r="http://schemas.openxmlformats.org/officeDocument/2006/relationships" id="2147483648" r:id="R803af3f524b74860"/>
   </p:sldMasterIdLst>
   <p:notesMasterIdLst>
-    <p:notesMasterId xmlns:r="http://schemas.openxmlformats.org/officeDocument/2006/relationships" r:id="R7d11d8dae7524620"/>
+    <p:notesMasterId xmlns:r="http://schemas.openxmlformats.org/officeDocument/2006/relationships" r:id="Reab2a91ece0a4bed"/>
   </p:notesMasterIdLst>
   <p:sldIdLst>
-    <p:sldId xmlns:r="http://schemas.openxmlformats.org/officeDocument/2006/relationships" id="256" r:id="R70af5a42fa1243fa"/>
-    <p:sldId xmlns:r="http://schemas.openxmlformats.org/officeDocument/2006/relationships" id="257" r:id="Rd97cecedd71c43d3"/>
-    <p:sldId xmlns:r="http://schemas.openxmlformats.org/officeDocument/2006/relationships" id="258" r:id="R07f8cb41e8f04d95"/>
-    <p:sldId xmlns:r="http://schemas.openxmlformats.org/officeDocument/2006/relationships" id="259" r:id="Ra571fae7f0174e5a"/>
-    <p:sldId xmlns:r="http://schemas.openxmlformats.org/officeDocument/2006/relationships" id="260" r:id="R75ecf20f97ae4dcb"/>
-    <p:sldId xmlns:r="http://schemas.openxmlformats.org/officeDocument/2006/relationships" id="261" r:id="R29a150bab71f4990"/>
-    <p:sldId xmlns:r="http://schemas.openxmlformats.org/officeDocument/2006/relationships" id="262" r:id="Rae16e80c9dd54a19"/>
-    <p:sldId xmlns:r="http://schemas.openxmlformats.org/officeDocument/2006/relationships" id="263" r:id="R67f008adf5ec4180"/>
-    <p:sldId xmlns:r="http://schemas.openxmlformats.org/officeDocument/2006/relationships" id="264" r:id="R8c79f23daca54bac"/>
+    <p:sldId xmlns:r="http://schemas.openxmlformats.org/officeDocument/2006/relationships" id="256" r:id="R89c33ddbc90641de"/>
+    <p:sldId xmlns:r="http://schemas.openxmlformats.org/officeDocument/2006/relationships" id="257" r:id="R9b2ebd4a80f04bd8"/>
+    <p:sldId xmlns:r="http://schemas.openxmlformats.org/officeDocument/2006/relationships" id="258" r:id="R740c7be2eb8542ae"/>
+    <p:sldId xmlns:r="http://schemas.openxmlformats.org/officeDocument/2006/relationships" id="259" r:id="R13448c344fc642a2"/>
+    <p:sldId xmlns:r="http://schemas.openxmlformats.org/officeDocument/2006/relationships" id="260" r:id="R0990aede6804436e"/>
+    <p:sldId xmlns:r="http://schemas.openxmlformats.org/officeDocument/2006/relationships" id="261" r:id="R5326deddf4104c8e"/>
+    <p:sldId xmlns:r="http://schemas.openxmlformats.org/officeDocument/2006/relationships" id="262" r:id="R736e14eab4834236"/>
+    <p:sldId xmlns:r="http://schemas.openxmlformats.org/officeDocument/2006/relationships" id="263" r:id="Rbd0d2752497043f7"/>
+    <p:sldId xmlns:r="http://schemas.openxmlformats.org/officeDocument/2006/relationships" id="264" r:id="Rc59784748c6a4263"/>
   </p:sldIdLst>
   <p:sldSz cx="12192000" cy="6858000"/>
   <p:notesSz cx="6858000" cy="9144000"/>
   <p:embeddedFontLst>
     <p:embeddedFont>
       <p:font typeface="JetBrains Mono"/>
-      <p:regular xmlns:r="http://schemas.openxmlformats.org/officeDocument/2006/relationships" r:id="R59a03fbf403c4da7"/>
+      <p:regular xmlns:r="http://schemas.openxmlformats.org/officeDocument/2006/relationships" r:id="Rc4a9dccf05734adb"/>
     </p:embeddedFont>
   </p:embeddedFontLst>
 </p:presentation>
@@ -1071,7 +1071,7 @@
           <p:nvPr/>
         </p:nvPicPr>
         <p:blipFill rotWithShape="1">
-          <a:blip xmlns:r="http://schemas.openxmlformats.org/officeDocument/2006/relationships" xmlns:a="http://schemas.openxmlformats.org/drawingml/2006/main" r:embed="R5b8c24a0e69d47f7"/>
+          <a:blip xmlns:r="http://schemas.openxmlformats.org/officeDocument/2006/relationships" xmlns:a="http://schemas.openxmlformats.org/drawingml/2006/main" r:embed="R26e7c0a25cd946d8"/>
           <a:stretch xmlns:a="http://schemas.openxmlformats.org/drawingml/2006/main"/>
         </p:blipFill>
         <p:spPr>
@@ -1451,7 +1451,7 @@
           <p:nvPr/>
         </p:nvPicPr>
         <p:blipFill rotWithShape="1">
-          <a:blip xmlns:r="http://schemas.openxmlformats.org/officeDocument/2006/relationships" xmlns:a="http://schemas.openxmlformats.org/drawingml/2006/main" r:embed="Rad97389592574150">
+          <a:blip xmlns:r="http://schemas.openxmlformats.org/officeDocument/2006/relationships" xmlns:a="http://schemas.openxmlformats.org/drawingml/2006/main" r:embed="Rd78a7bf7794b4929">
             <a:alphaModFix amt="28000"/>
           </a:blip>
           <a:stretch xmlns:a="http://schemas.openxmlformats.org/drawingml/2006/main"/>
@@ -1664,7 +1664,7 @@
           <p:nvPr/>
         </p:nvPicPr>
         <p:blipFill rotWithShape="1">
-          <a:blip xmlns:r="http://schemas.openxmlformats.org/officeDocument/2006/relationships" xmlns:a="http://schemas.openxmlformats.org/drawingml/2006/main" r:embed="R8597543349874cc8">
+          <a:blip xmlns:r="http://schemas.openxmlformats.org/officeDocument/2006/relationships" xmlns:a="http://schemas.openxmlformats.org/drawingml/2006/main" r:embed="R4dbdb53349f24ede">
             <a:alphaModFix amt="28000"/>
           </a:blip>
           <a:stretch xmlns:a="http://schemas.openxmlformats.org/drawingml/2006/main"/>
@@ -1899,7 +1899,7 @@
           <p:nvPr/>
         </p:nvPicPr>
         <p:blipFill rotWithShape="1">
-          <a:blip xmlns:r="http://schemas.openxmlformats.org/officeDocument/2006/relationships" xmlns:a="http://schemas.openxmlformats.org/drawingml/2006/main" r:embed="R544632c0ec8c4055">
+          <a:blip xmlns:r="http://schemas.openxmlformats.org/officeDocument/2006/relationships" xmlns:a="http://schemas.openxmlformats.org/drawingml/2006/main" r:embed="R1ad3a1c268d44786">
             <a:alphaModFix amt="28000"/>
           </a:blip>
           <a:stretch xmlns:a="http://schemas.openxmlformats.org/drawingml/2006/main"/>
@@ -2176,7 +2176,7 @@
           <p:nvPr/>
         </p:nvPicPr>
         <p:blipFill rotWithShape="1">
-          <a:blip xmlns:r="http://schemas.openxmlformats.org/officeDocument/2006/relationships" xmlns:a="http://schemas.openxmlformats.org/drawingml/2006/main" r:embed="R6f9ad4229a2546a9">
+          <a:blip xmlns:r="http://schemas.openxmlformats.org/officeDocument/2006/relationships" xmlns:a="http://schemas.openxmlformats.org/drawingml/2006/main" r:embed="Raf1d82fded814072">
             <a:alphaModFix amt="28000"/>
           </a:blip>
           <a:stretch xmlns:a="http://schemas.openxmlformats.org/drawingml/2006/main"/>
@@ -2451,7 +2451,7 @@
           <p:nvPr/>
         </p:nvPicPr>
         <p:blipFill rotWithShape="1">
-          <a:blip xmlns:r="http://schemas.openxmlformats.org/officeDocument/2006/relationships" xmlns:a="http://schemas.openxmlformats.org/drawingml/2006/main" r:embed="R79f15aa0ed494aab">
+          <a:blip xmlns:r="http://schemas.openxmlformats.org/officeDocument/2006/relationships" xmlns:a="http://schemas.openxmlformats.org/drawingml/2006/main" r:embed="R1f013566cd564a04">
             <a:alphaModFix amt="28000"/>
           </a:blip>
           <a:stretch xmlns:a="http://schemas.openxmlformats.org/drawingml/2006/main"/>
@@ -2875,7 +2875,7 @@
           <p:nvPr/>
         </p:nvPicPr>
         <p:blipFill rotWithShape="1">
-          <a:blip xmlns:r="http://schemas.openxmlformats.org/officeDocument/2006/relationships" xmlns:a="http://schemas.openxmlformats.org/drawingml/2006/main" r:embed="Rdd1a5cb3129c4bad">
+          <a:blip xmlns:r="http://schemas.openxmlformats.org/officeDocument/2006/relationships" xmlns:a="http://schemas.openxmlformats.org/drawingml/2006/main" r:embed="Ra9d25cd3cb9a4d0e">
             <a:alphaModFix amt="28000"/>
           </a:blip>
           <a:stretch xmlns:a="http://schemas.openxmlformats.org/drawingml/2006/main"/>
@@ -3016,7 +3016,7 @@
           <p:nvPr/>
         </p:nvPicPr>
         <p:blipFill rotWithShape="1">
-          <a:blip xmlns:r="http://schemas.openxmlformats.org/officeDocument/2006/relationships" xmlns:a="http://schemas.openxmlformats.org/drawingml/2006/main" r:embed="Rd06a8e7c89f64807">
+          <a:blip xmlns:r="http://schemas.openxmlformats.org/officeDocument/2006/relationships" xmlns:a="http://schemas.openxmlformats.org/drawingml/2006/main" r:embed="R146948d11db34781">
             <a:alphaModFix amt="28000"/>
           </a:blip>
           <a:stretch xmlns:a="http://schemas.openxmlformats.org/drawingml/2006/main"/>
@@ -3130,7 +3130,7 @@
           <p:nvPr/>
         </p:nvPicPr>
         <p:blipFill rotWithShape="1">
-          <a:blip xmlns:r="http://schemas.openxmlformats.org/officeDocument/2006/relationships" xmlns:a="http://schemas.openxmlformats.org/drawingml/2006/main" r:embed="R2ea275f0dd9a43d5">
+          <a:blip xmlns:r="http://schemas.openxmlformats.org/officeDocument/2006/relationships" xmlns:a="http://schemas.openxmlformats.org/drawingml/2006/main" r:embed="Rf03f01fa4cf045cd">
             <a:alphaModFix amt="28000"/>
           </a:blip>
           <a:stretch xmlns:a="http://schemas.openxmlformats.org/drawingml/2006/main"/>
@@ -3457,7 +3457,7 @@
           <p:nvPr/>
         </p:nvPicPr>
         <p:blipFill rotWithShape="1">
-          <a:blip xmlns:r="http://schemas.openxmlformats.org/officeDocument/2006/relationships" xmlns:a="http://schemas.openxmlformats.org/drawingml/2006/main" r:embed="Raa392964982e4be8">
+          <a:blip xmlns:r="http://schemas.openxmlformats.org/officeDocument/2006/relationships" xmlns:a="http://schemas.openxmlformats.org/drawingml/2006/main" r:embed="R6b7b4c4161534c5f">
             <a:alphaModFix amt="28000"/>
           </a:blip>
           <a:stretch xmlns:a="http://schemas.openxmlformats.org/drawingml/2006/main"/>
@@ -3745,7 +3745,7 @@
           <p:nvPr/>
         </p:nvPicPr>
         <p:blipFill rotWithShape="1">
-          <a:blip xmlns:r="http://schemas.openxmlformats.org/officeDocument/2006/relationships" xmlns:a="http://schemas.openxmlformats.org/drawingml/2006/main" r:embed="R3bab0e99a4234b73">
+          <a:blip xmlns:r="http://schemas.openxmlformats.org/officeDocument/2006/relationships" xmlns:a="http://schemas.openxmlformats.org/drawingml/2006/main" r:embed="Re5d27811e9e747ea">
             <a:alphaModFix amt="28000"/>
           </a:blip>
           <a:stretch xmlns:a="http://schemas.openxmlformats.org/drawingml/2006/main"/>
@@ -3982,17 +3982,17 @@
   </p:cSld>
   <p:clrMap bg1="lt1" tx1="dk1" bg2="lt2" tx2="dk2" accent1="accent1" accent2="accent2" accent3="accent3" accent4="accent4" accent5="accent5" accent6="accent6" hlink="hlink" folHlink="folHlink"/>
   <p:sldLayoutIdLst>
-    <p:sldLayoutId xmlns:r="http://schemas.openxmlformats.org/officeDocument/2006/relationships" id="2147483649" r:id="Rbe63e112a636429a"/>
-    <p:sldLayoutId xmlns:r="http://schemas.openxmlformats.org/officeDocument/2006/relationships" id="2147483650" r:id="Rb563408283d740f1"/>
-    <p:sldLayoutId xmlns:r="http://schemas.openxmlformats.org/officeDocument/2006/relationships" id="2147483651" r:id="R3d7b43fca9bd449b"/>
-    <p:sldLayoutId xmlns:r="http://schemas.openxmlformats.org/officeDocument/2006/relationships" id="2147483652" r:id="Rb9bf26fb22f34e12"/>
-    <p:sldLayoutId xmlns:r="http://schemas.openxmlformats.org/officeDocument/2006/relationships" id="2147483653" r:id="Rfabb5a42d8694056"/>
-    <p:sldLayoutId xmlns:r="http://schemas.openxmlformats.org/officeDocument/2006/relationships" id="2147483654" r:id="Rfc482e378d0d47b0"/>
-    <p:sldLayoutId xmlns:r="http://schemas.openxmlformats.org/officeDocument/2006/relationships" id="2147483655" r:id="R7098ad8e43c44af8"/>
-    <p:sldLayoutId xmlns:r="http://schemas.openxmlformats.org/officeDocument/2006/relationships" id="2147483656" r:id="Rb71baf6a369f447d"/>
-    <p:sldLayoutId xmlns:r="http://schemas.openxmlformats.org/officeDocument/2006/relationships" id="2147483657" r:id="Rfc8dddcd98e74230"/>
-    <p:sldLayoutId xmlns:r="http://schemas.openxmlformats.org/officeDocument/2006/relationships" id="2147483658" r:id="Rf18ee895bdcd47d1"/>
-    <p:sldLayoutId xmlns:r="http://schemas.openxmlformats.org/officeDocument/2006/relationships" id="2147483659" r:id="R0b257a785972475c"/>
+    <p:sldLayoutId xmlns:r="http://schemas.openxmlformats.org/officeDocument/2006/relationships" id="2147483649" r:id="R1c0bdc59f3494879"/>
+    <p:sldLayoutId xmlns:r="http://schemas.openxmlformats.org/officeDocument/2006/relationships" id="2147483650" r:id="R320d4132cd2d47d6"/>
+    <p:sldLayoutId xmlns:r="http://schemas.openxmlformats.org/officeDocument/2006/relationships" id="2147483651" r:id="Raa8622b3df1140d9"/>
+    <p:sldLayoutId xmlns:r="http://schemas.openxmlformats.org/officeDocument/2006/relationships" id="2147483652" r:id="Redd1fe57e4dc4a9b"/>
+    <p:sldLayoutId xmlns:r="http://schemas.openxmlformats.org/officeDocument/2006/relationships" id="2147483653" r:id="Rccc3fa261d7c402f"/>
+    <p:sldLayoutId xmlns:r="http://schemas.openxmlformats.org/officeDocument/2006/relationships" id="2147483654" r:id="R66f8609f453b4add"/>
+    <p:sldLayoutId xmlns:r="http://schemas.openxmlformats.org/officeDocument/2006/relationships" id="2147483655" r:id="R51127d00352c4dce"/>
+    <p:sldLayoutId xmlns:r="http://schemas.openxmlformats.org/officeDocument/2006/relationships" id="2147483656" r:id="R62c83e1b367e44dc"/>
+    <p:sldLayoutId xmlns:r="http://schemas.openxmlformats.org/officeDocument/2006/relationships" id="2147483657" r:id="R77ddb7ac439e4ea0"/>
+    <p:sldLayoutId xmlns:r="http://schemas.openxmlformats.org/officeDocument/2006/relationships" id="2147483658" r:id="Rff82dffbc83542c8"/>
+    <p:sldLayoutId xmlns:r="http://schemas.openxmlformats.org/officeDocument/2006/relationships" id="2147483659" r:id="R0fa2abb16aac4ffe"/>
   </p:sldLayoutIdLst>
   <p:hf hdr="0" ftr="0" dt="0"/>
   <p:txStyles>
@@ -6688,10 +6688,10 @@
                 <a:ea typeface="Calibri"/>
                 <a:cs typeface="Calibri"/>
               </a:rPr>
-              <a:t>Store a greeting from another language, such as </a:t>
-            </a:r>
-            <a:r>
-              <a:rPr sz="2400" b="0">
+              <a:t>Change the example so it stores a greeting in another language, such as </a:t>
+            </a:r>
+            <a:r>
+              <a:rPr sz="2050" b="0">
                 <a:solidFill>
                   <a:srgbClr val="067D17"/>
                 </a:solidFill>
@@ -6710,18 +6710,21 @@
                 <a:ea typeface="Calibri"/>
                 <a:cs typeface="Calibri"/>
               </a:rPr>
-              <a:t>, in a variable called [greeting]. Change </a:t>
-            </a:r>
-            <a:r>
-              <a:rPr sz="2400" b="0">
-                <a:solidFill>
-                  <a:srgbClr val="1750EB"/>
-                </a:solidFill>
-                <a:latin typeface="JetBrains Mono"/>
-                <a:ea typeface="JetBrains Mono"/>
-                <a:cs typeface="JetBrains Mono"/>
-              </a:rPr>
-              <a:t>print()</a:t>
+              <a:t>, in </a:t>
+            </a:r>
+            <a:r>
+              <a:rPr sz="2050" b="0">
+                <a:solidFill>
+                  <a:srgbClr val="6A1B9A"/>
+                </a:solidFill>
+                <a:highlight>
+                  <a:srgbClr val="ECEAF4"/>
+                </a:highlight>
+                <a:latin typeface="JetBrains Mono"/>
+                <a:ea typeface="JetBrains Mono"/>
+                <a:cs typeface="JetBrains Mono"/>
+              </a:rPr>
+              <a:t> greeting </a:t>
             </a:r>
             <a:r>
               <a:rPr sz="2400" b="0">
@@ -6732,7 +6735,101 @@
                 <a:ea typeface="Calibri"/>
                 <a:cs typeface="Calibri"/>
               </a:rPr>
-              <a:t> so it displays [greeting], then [name], then an exclamation mark.</a:t>
+              <a:t>. Change </a:t>
+            </a:r>
+            <a:r>
+              <a:rPr sz="2050" b="0">
+                <a:solidFill>
+                  <a:srgbClr val="1750EB"/>
+                </a:solidFill>
+                <a:latin typeface="JetBrains Mono"/>
+                <a:ea typeface="JetBrains Mono"/>
+                <a:cs typeface="JetBrains Mono"/>
+              </a:rPr>
+              <a:t>print()</a:t>
+            </a:r>
+            <a:r>
+              <a:rPr sz="2400" b="0">
+                <a:solidFill>
+                  <a:srgbClr val="080808"/>
+                </a:solidFill>
+                <a:latin typeface="Calibri"/>
+                <a:ea typeface="Calibri"/>
+                <a:cs typeface="Calibri"/>
+              </a:rPr>
+              <a:t> to display </a:t>
+            </a:r>
+            <a:r>
+              <a:rPr sz="2050" b="0">
+                <a:solidFill>
+                  <a:srgbClr val="6A1B9A"/>
+                </a:solidFill>
+                <a:highlight>
+                  <a:srgbClr val="ECEAF4"/>
+                </a:highlight>
+                <a:latin typeface="JetBrains Mono"/>
+                <a:ea typeface="JetBrains Mono"/>
+                <a:cs typeface="JetBrains Mono"/>
+              </a:rPr>
+              <a:t> greeting </a:t>
+            </a:r>
+            <a:r>
+              <a:rPr sz="2400" b="0">
+                <a:solidFill>
+                  <a:srgbClr val="080808"/>
+                </a:solidFill>
+                <a:latin typeface="Calibri"/>
+                <a:ea typeface="Calibri"/>
+                <a:cs typeface="Calibri"/>
+              </a:rPr>
+              <a:t>, then </a:t>
+            </a:r>
+            <a:r>
+              <a:rPr sz="2050" b="0">
+                <a:solidFill>
+                  <a:srgbClr val="6A1B9A"/>
+                </a:solidFill>
+                <a:highlight>
+                  <a:srgbClr val="ECEAF4"/>
+                </a:highlight>
+                <a:latin typeface="JetBrains Mono"/>
+                <a:ea typeface="JetBrains Mono"/>
+                <a:cs typeface="JetBrains Mono"/>
+              </a:rPr>
+              <a:t> name </a:t>
+            </a:r>
+            <a:r>
+              <a:rPr sz="2400" b="0">
+                <a:solidFill>
+                  <a:srgbClr val="080808"/>
+                </a:solidFill>
+                <a:latin typeface="Calibri"/>
+                <a:ea typeface="Calibri"/>
+                <a:cs typeface="Calibri"/>
+              </a:rPr>
+              <a:t>, then </a:t>
+            </a:r>
+            <a:r>
+              <a:rPr sz="2050" b="0">
+                <a:solidFill>
+                  <a:srgbClr val="067D17"/>
+                </a:solidFill>
+                <a:latin typeface="JetBrains Mono"/>
+                <a:ea typeface="JetBrains Mono"/>
+                <a:cs typeface="JetBrains Mono"/>
+              </a:rPr>
+              <a:t>"!"</a:t>
+            </a:r>
+            <a:r>
+              <a:rPr sz="2400" b="0">
+                <a:solidFill>
+                  <a:srgbClr val="080808"/>
+                </a:solidFill>
+                <a:latin typeface="Calibri"/>
+                <a:ea typeface="Calibri"/>
+                <a:cs typeface="Calibri"/>
+              </a:rPr>
+              <a:t>.</a:t>
             </a:r>
           </a:p>
         </p:txBody>
@@ -7248,18 +7345,21 @@
                 <a:ea typeface="Calibri"/>
                 <a:cs typeface="Calibri"/>
               </a:rPr>
-              <a:t>Ask for a friend's name and store it in a variable called [friend_name]. Change </a:t>
-            </a:r>
-            <a:r>
-              <a:rPr sz="2400" b="0">
-                <a:solidFill>
-                  <a:srgbClr val="1750EB"/>
-                </a:solidFill>
-                <a:latin typeface="JetBrains Mono"/>
-                <a:ea typeface="JetBrains Mono"/>
-                <a:cs typeface="JetBrains Mono"/>
-              </a:rPr>
-              <a:t>print()</a:t>
+              <a:t>Extend the example so it also asks for a friend's name and stores it in </a:t>
+            </a:r>
+            <a:r>
+              <a:rPr sz="2050" b="0">
+                <a:solidFill>
+                  <a:srgbClr val="6A1B9A"/>
+                </a:solidFill>
+                <a:highlight>
+                  <a:srgbClr val="ECEAF4"/>
+                </a:highlight>
+                <a:latin typeface="JetBrains Mono"/>
+                <a:ea typeface="JetBrains Mono"/>
+                <a:cs typeface="JetBrains Mono"/>
+              </a:rPr>
+              <a:t> friend_name </a:t>
             </a:r>
             <a:r>
               <a:rPr sz="2400" b="0">
@@ -7270,10 +7370,10 @@
                 <a:ea typeface="Calibri"/>
                 <a:cs typeface="Calibri"/>
               </a:rPr>
-              <a:t> so it displays </a:t>
-            </a:r>
-            <a:r>
-              <a:rPr sz="2400" b="0">
+              <a:t>. Display </a:t>
+            </a:r>
+            <a:r>
+              <a:rPr sz="2050" b="0">
                 <a:solidFill>
                   <a:srgbClr val="067D17"/>
                 </a:solidFill>
@@ -7281,7 +7381,7 @@
                 <a:ea typeface="JetBrains Mono"/>
                 <a:cs typeface="JetBrains Mono"/>
               </a:rPr>
-              <a:t>"Hello, [name] and [friend_name]!"</a:t>
+              <a:t>"Hello,"</a:t>
             </a:r>
             <a:r>
               <a:rPr sz="2400" b="0">
@@ -7292,7 +7392,101 @@
                 <a:ea typeface="Calibri"/>
                 <a:cs typeface="Calibri"/>
               </a:rPr>
-              <a:t> using [name] and [friend_name].</a:t>
+              <a:t> followed by </a:t>
+            </a:r>
+            <a:r>
+              <a:rPr sz="2050" b="0">
+                <a:solidFill>
+                  <a:srgbClr val="6A1B9A"/>
+                </a:solidFill>
+                <a:highlight>
+                  <a:srgbClr val="ECEAF4"/>
+                </a:highlight>
+                <a:latin typeface="JetBrains Mono"/>
+                <a:ea typeface="JetBrains Mono"/>
+                <a:cs typeface="JetBrains Mono"/>
+              </a:rPr>
+              <a:t> name </a:t>
+            </a:r>
+            <a:r>
+              <a:rPr sz="2400" b="0">
+                <a:solidFill>
+                  <a:srgbClr val="080808"/>
+                </a:solidFill>
+                <a:latin typeface="Calibri"/>
+                <a:ea typeface="Calibri"/>
+                <a:cs typeface="Calibri"/>
+              </a:rPr>
+              <a:t>, </a:t>
+            </a:r>
+            <a:r>
+              <a:rPr sz="2050" b="0">
+                <a:solidFill>
+                  <a:srgbClr val="067D17"/>
+                </a:solidFill>
+                <a:latin typeface="JetBrains Mono"/>
+                <a:ea typeface="JetBrains Mono"/>
+                <a:cs typeface="JetBrains Mono"/>
+              </a:rPr>
+              <a:t>"and"</a:t>
+            </a:r>
+            <a:r>
+              <a:rPr sz="2400" b="0">
+                <a:solidFill>
+                  <a:srgbClr val="080808"/>
+                </a:solidFill>
+                <a:latin typeface="Calibri"/>
+                <a:ea typeface="Calibri"/>
+                <a:cs typeface="Calibri"/>
+              </a:rPr>
+              <a:t>, </a:t>
+            </a:r>
+            <a:r>
+              <a:rPr sz="2050" b="0">
+                <a:solidFill>
+                  <a:srgbClr val="6A1B9A"/>
+                </a:solidFill>
+                <a:highlight>
+                  <a:srgbClr val="ECEAF4"/>
+                </a:highlight>
+                <a:latin typeface="JetBrains Mono"/>
+                <a:ea typeface="JetBrains Mono"/>
+                <a:cs typeface="JetBrains Mono"/>
+              </a:rPr>
+              <a:t> friend_name </a:t>
+            </a:r>
+            <a:r>
+              <a:rPr sz="2400" b="0">
+                <a:solidFill>
+                  <a:srgbClr val="080808"/>
+                </a:solidFill>
+                <a:latin typeface="Calibri"/>
+                <a:ea typeface="Calibri"/>
+                <a:cs typeface="Calibri"/>
+              </a:rPr>
+              <a:t> and </a:t>
+            </a:r>
+            <a:r>
+              <a:rPr sz="2050" b="0">
+                <a:solidFill>
+                  <a:srgbClr val="067D17"/>
+                </a:solidFill>
+                <a:latin typeface="JetBrains Mono"/>
+                <a:ea typeface="JetBrains Mono"/>
+                <a:cs typeface="JetBrains Mono"/>
+              </a:rPr>
+              <a:t>"!"</a:t>
+            </a:r>
+            <a:r>
+              <a:rPr sz="2400" b="0">
+                <a:solidFill>
+                  <a:srgbClr val="080808"/>
+                </a:solidFill>
+                <a:latin typeface="Calibri"/>
+                <a:ea typeface="Calibri"/>
+                <a:cs typeface="Calibri"/>
+              </a:rPr>
+              <a:t>.</a:t>
             </a:r>
           </a:p>
         </p:txBody>
@@ -7808,18 +8002,21 @@
                 <a:ea typeface="Calibri"/>
                 <a:cs typeface="Calibri"/>
               </a:rPr>
-              <a:t>Create a new program that asks for two school subjects. Display the message </a:t>
-            </a:r>
-            <a:r>
-              <a:rPr sz="2400" b="0">
-                <a:solidFill>
-                  <a:srgbClr val="067D17"/>
-                </a:solidFill>
-                <a:latin typeface="JetBrains Mono"/>
-                <a:ea typeface="JetBrains Mono"/>
-                <a:cs typeface="JetBrains Mono"/>
-              </a:rPr>
-              <a:t>"I think [subject 1] and [subject 2] are great subjects!"</a:t>
+              <a:t>Create a program that asks for two school subjects and stores them in </a:t>
+            </a:r>
+            <a:r>
+              <a:rPr sz="2050" b="0">
+                <a:solidFill>
+                  <a:srgbClr val="6A1B9A"/>
+                </a:solidFill>
+                <a:highlight>
+                  <a:srgbClr val="ECEAF4"/>
+                </a:highlight>
+                <a:latin typeface="JetBrains Mono"/>
+                <a:ea typeface="JetBrains Mono"/>
+                <a:cs typeface="JetBrains Mono"/>
+              </a:rPr>
+              <a:t> subject_1 </a:t>
             </a:r>
             <a:r>
               <a:rPr sz="2400" b="0">
@@ -7830,7 +8027,104 @@
                 <a:ea typeface="Calibri"/>
                 <a:cs typeface="Calibri"/>
               </a:rPr>
-              <a:t> using the two answers.</a:t>
+              <a:t> and </a:t>
+            </a:r>
+            <a:r>
+              <a:rPr sz="2050" b="0">
+                <a:solidFill>
+                  <a:srgbClr val="6A1B9A"/>
+                </a:solidFill>
+                <a:highlight>
+                  <a:srgbClr val="ECEAF4"/>
+                </a:highlight>
+                <a:latin typeface="JetBrains Mono"/>
+                <a:ea typeface="JetBrains Mono"/>
+                <a:cs typeface="JetBrains Mono"/>
+              </a:rPr>
+              <a:t> subject_2 </a:t>
+            </a:r>
+            <a:r>
+              <a:rPr sz="2400" b="0">
+                <a:solidFill>
+                  <a:srgbClr val="080808"/>
+                </a:solidFill>
+                <a:latin typeface="Calibri"/>
+                <a:ea typeface="Calibri"/>
+                <a:cs typeface="Calibri"/>
+              </a:rPr>
+              <a:t>. Display </a:t>
+            </a:r>
+            <a:r>
+              <a:rPr sz="2050" b="0">
+                <a:solidFill>
+                  <a:srgbClr val="067D17"/>
+                </a:solidFill>
+                <a:latin typeface="JetBrains Mono"/>
+                <a:ea typeface="JetBrains Mono"/>
+                <a:cs typeface="JetBrains Mono"/>
+              </a:rPr>
+              <a:t>"I think </a:t>
+            </a:r>
+            <a:r>
+              <a:rPr sz="2050" b="0">
+                <a:solidFill>
+                  <a:srgbClr val="6A1B9A"/>
+                </a:solidFill>
+                <a:highlight>
+                  <a:srgbClr val="ECEAF4"/>
+                </a:highlight>
+                <a:latin typeface="JetBrains Mono"/>
+                <a:ea typeface="JetBrains Mono"/>
+                <a:cs typeface="JetBrains Mono"/>
+              </a:rPr>
+              <a:t> subject_1 </a:t>
+            </a:r>
+            <a:r>
+              <a:rPr sz="2050" b="0">
+                <a:solidFill>
+                  <a:srgbClr val="067D17"/>
+                </a:solidFill>
+                <a:latin typeface="JetBrains Mono"/>
+                <a:ea typeface="JetBrains Mono"/>
+                <a:cs typeface="JetBrains Mono"/>
+              </a:rPr>
+              <a:t> and </a:t>
+            </a:r>
+            <a:r>
+              <a:rPr sz="2050" b="0">
+                <a:solidFill>
+                  <a:srgbClr val="6A1B9A"/>
+                </a:solidFill>
+                <a:highlight>
+                  <a:srgbClr val="ECEAF4"/>
+                </a:highlight>
+                <a:latin typeface="JetBrains Mono"/>
+                <a:ea typeface="JetBrains Mono"/>
+                <a:cs typeface="JetBrains Mono"/>
+              </a:rPr>
+              <a:t> subject_2 </a:t>
+            </a:r>
+            <a:r>
+              <a:rPr sz="2050" b="0">
+                <a:solidFill>
+                  <a:srgbClr val="067D17"/>
+                </a:solidFill>
+                <a:latin typeface="JetBrains Mono"/>
+                <a:ea typeface="JetBrains Mono"/>
+                <a:cs typeface="JetBrains Mono"/>
+              </a:rPr>
+              <a:t> are great subjects!"</a:t>
+            </a:r>
+            <a:r>
+              <a:rPr sz="2400" b="0">
+                <a:solidFill>
+                  <a:srgbClr val="080808"/>
+                </a:solidFill>
+                <a:latin typeface="Calibri"/>
+                <a:ea typeface="Calibri"/>
+                <a:cs typeface="Calibri"/>
+              </a:rPr>
+              <a:t>.</a:t>
             </a:r>
           </a:p>
         </p:txBody>

</xml_diff>

<commit_message>
feat: colour Python keywords orange in lesson code
Keywords (if, elif, else, for, while, def, return, and/or/not/in,
True/False) now use a PyCharm-style orange (#C45E00) in slides and
worksheets, separate from the blue used for calls and types. Rebuilt all
lessons and capstones.

Co-Authored-By: Claude Opus 5.5 <noreply@anthropic.com>
</commit_message>
<xml_diff>
--- a/Mapped Curriculum Lessons/Grade 6/Lesson 01 - Hello Python!/Hello Python! - Slides.pptx
+++ b/Mapped Curriculum Lessons/Grade 6/Lesson 01 - Hello Python!/Hello Python! - Slides.pptx
@@ -2,28 +2,28 @@
 <file path=ppt/presentation.xml><?xml version="1.0" encoding="utf-8"?>
 <p:presentation xmlns:p="http://schemas.openxmlformats.org/presentationml/2006/main" embedTrueTypeFonts="1" saveSubsetFonts="0">
   <p:sldMasterIdLst>
-    <p:sldMasterId xmlns:r="http://schemas.openxmlformats.org/officeDocument/2006/relationships" id="2147483648" r:id="R803af3f524b74860"/>
+    <p:sldMasterId xmlns:r="http://schemas.openxmlformats.org/officeDocument/2006/relationships" id="2147483648" r:id="Rdc7d04087ff34087"/>
   </p:sldMasterIdLst>
   <p:notesMasterIdLst>
-    <p:notesMasterId xmlns:r="http://schemas.openxmlformats.org/officeDocument/2006/relationships" r:id="Reab2a91ece0a4bed"/>
+    <p:notesMasterId xmlns:r="http://schemas.openxmlformats.org/officeDocument/2006/relationships" r:id="R8fae1f3662694304"/>
   </p:notesMasterIdLst>
   <p:sldIdLst>
-    <p:sldId xmlns:r="http://schemas.openxmlformats.org/officeDocument/2006/relationships" id="256" r:id="R89c33ddbc90641de"/>
-    <p:sldId xmlns:r="http://schemas.openxmlformats.org/officeDocument/2006/relationships" id="257" r:id="R9b2ebd4a80f04bd8"/>
-    <p:sldId xmlns:r="http://schemas.openxmlformats.org/officeDocument/2006/relationships" id="258" r:id="R740c7be2eb8542ae"/>
-    <p:sldId xmlns:r="http://schemas.openxmlformats.org/officeDocument/2006/relationships" id="259" r:id="R13448c344fc642a2"/>
-    <p:sldId xmlns:r="http://schemas.openxmlformats.org/officeDocument/2006/relationships" id="260" r:id="R0990aede6804436e"/>
-    <p:sldId xmlns:r="http://schemas.openxmlformats.org/officeDocument/2006/relationships" id="261" r:id="R5326deddf4104c8e"/>
-    <p:sldId xmlns:r="http://schemas.openxmlformats.org/officeDocument/2006/relationships" id="262" r:id="R736e14eab4834236"/>
-    <p:sldId xmlns:r="http://schemas.openxmlformats.org/officeDocument/2006/relationships" id="263" r:id="Rbd0d2752497043f7"/>
-    <p:sldId xmlns:r="http://schemas.openxmlformats.org/officeDocument/2006/relationships" id="264" r:id="Rc59784748c6a4263"/>
+    <p:sldId xmlns:r="http://schemas.openxmlformats.org/officeDocument/2006/relationships" id="256" r:id="R6ba6ddb55452494f"/>
+    <p:sldId xmlns:r="http://schemas.openxmlformats.org/officeDocument/2006/relationships" id="257" r:id="Ree03896ffd50440f"/>
+    <p:sldId xmlns:r="http://schemas.openxmlformats.org/officeDocument/2006/relationships" id="258" r:id="R1af86deb54c04f00"/>
+    <p:sldId xmlns:r="http://schemas.openxmlformats.org/officeDocument/2006/relationships" id="259" r:id="R4f79ff7b1b884161"/>
+    <p:sldId xmlns:r="http://schemas.openxmlformats.org/officeDocument/2006/relationships" id="260" r:id="R62ce80462e8749a7"/>
+    <p:sldId xmlns:r="http://schemas.openxmlformats.org/officeDocument/2006/relationships" id="261" r:id="R3b66a536e3fa4652"/>
+    <p:sldId xmlns:r="http://schemas.openxmlformats.org/officeDocument/2006/relationships" id="262" r:id="Rb691c8a34ed1476d"/>
+    <p:sldId xmlns:r="http://schemas.openxmlformats.org/officeDocument/2006/relationships" id="263" r:id="R2519f9e3ea5044fe"/>
+    <p:sldId xmlns:r="http://schemas.openxmlformats.org/officeDocument/2006/relationships" id="264" r:id="Rdb535a74e0a94127"/>
   </p:sldIdLst>
   <p:sldSz cx="12192000" cy="6858000"/>
   <p:notesSz cx="6858000" cy="9144000"/>
   <p:embeddedFontLst>
     <p:embeddedFont>
       <p:font typeface="JetBrains Mono"/>
-      <p:regular xmlns:r="http://schemas.openxmlformats.org/officeDocument/2006/relationships" r:id="Rc4a9dccf05734adb"/>
+      <p:regular xmlns:r="http://schemas.openxmlformats.org/officeDocument/2006/relationships" r:id="R6212d3e028b94548"/>
     </p:embeddedFont>
   </p:embeddedFontLst>
 </p:presentation>
@@ -1071,7 +1071,7 @@
           <p:nvPr/>
         </p:nvPicPr>
         <p:blipFill rotWithShape="1">
-          <a:blip xmlns:r="http://schemas.openxmlformats.org/officeDocument/2006/relationships" xmlns:a="http://schemas.openxmlformats.org/drawingml/2006/main" r:embed="R26e7c0a25cd946d8"/>
+          <a:blip xmlns:r="http://schemas.openxmlformats.org/officeDocument/2006/relationships" xmlns:a="http://schemas.openxmlformats.org/drawingml/2006/main" r:embed="R1ece304c4b1d4c07"/>
           <a:stretch xmlns:a="http://schemas.openxmlformats.org/drawingml/2006/main"/>
         </p:blipFill>
         <p:spPr>
@@ -1451,7 +1451,7 @@
           <p:nvPr/>
         </p:nvPicPr>
         <p:blipFill rotWithShape="1">
-          <a:blip xmlns:r="http://schemas.openxmlformats.org/officeDocument/2006/relationships" xmlns:a="http://schemas.openxmlformats.org/drawingml/2006/main" r:embed="Rd78a7bf7794b4929">
+          <a:blip xmlns:r="http://schemas.openxmlformats.org/officeDocument/2006/relationships" xmlns:a="http://schemas.openxmlformats.org/drawingml/2006/main" r:embed="Raaf39e412f624b1e">
             <a:alphaModFix amt="28000"/>
           </a:blip>
           <a:stretch xmlns:a="http://schemas.openxmlformats.org/drawingml/2006/main"/>
@@ -1664,7 +1664,7 @@
           <p:nvPr/>
         </p:nvPicPr>
         <p:blipFill rotWithShape="1">
-          <a:blip xmlns:r="http://schemas.openxmlformats.org/officeDocument/2006/relationships" xmlns:a="http://schemas.openxmlformats.org/drawingml/2006/main" r:embed="R4dbdb53349f24ede">
+          <a:blip xmlns:r="http://schemas.openxmlformats.org/officeDocument/2006/relationships" xmlns:a="http://schemas.openxmlformats.org/drawingml/2006/main" r:embed="R61121419c5fd4a71">
             <a:alphaModFix amt="28000"/>
           </a:blip>
           <a:stretch xmlns:a="http://schemas.openxmlformats.org/drawingml/2006/main"/>
@@ -1899,7 +1899,7 @@
           <p:nvPr/>
         </p:nvPicPr>
         <p:blipFill rotWithShape="1">
-          <a:blip xmlns:r="http://schemas.openxmlformats.org/officeDocument/2006/relationships" xmlns:a="http://schemas.openxmlformats.org/drawingml/2006/main" r:embed="R1ad3a1c268d44786">
+          <a:blip xmlns:r="http://schemas.openxmlformats.org/officeDocument/2006/relationships" xmlns:a="http://schemas.openxmlformats.org/drawingml/2006/main" r:embed="Rbb99d5f99df14d2c">
             <a:alphaModFix amt="28000"/>
           </a:blip>
           <a:stretch xmlns:a="http://schemas.openxmlformats.org/drawingml/2006/main"/>
@@ -2176,7 +2176,7 @@
           <p:nvPr/>
         </p:nvPicPr>
         <p:blipFill rotWithShape="1">
-          <a:blip xmlns:r="http://schemas.openxmlformats.org/officeDocument/2006/relationships" xmlns:a="http://schemas.openxmlformats.org/drawingml/2006/main" r:embed="Raf1d82fded814072">
+          <a:blip xmlns:r="http://schemas.openxmlformats.org/officeDocument/2006/relationships" xmlns:a="http://schemas.openxmlformats.org/drawingml/2006/main" r:embed="R86e60a1420ab458e">
             <a:alphaModFix amt="28000"/>
           </a:blip>
           <a:stretch xmlns:a="http://schemas.openxmlformats.org/drawingml/2006/main"/>
@@ -2451,7 +2451,7 @@
           <p:nvPr/>
         </p:nvPicPr>
         <p:blipFill rotWithShape="1">
-          <a:blip xmlns:r="http://schemas.openxmlformats.org/officeDocument/2006/relationships" xmlns:a="http://schemas.openxmlformats.org/drawingml/2006/main" r:embed="R1f013566cd564a04">
+          <a:blip xmlns:r="http://schemas.openxmlformats.org/officeDocument/2006/relationships" xmlns:a="http://schemas.openxmlformats.org/drawingml/2006/main" r:embed="Ra7370ab2f0f44d56">
             <a:alphaModFix amt="28000"/>
           </a:blip>
           <a:stretch xmlns:a="http://schemas.openxmlformats.org/drawingml/2006/main"/>
@@ -2875,7 +2875,7 @@
           <p:nvPr/>
         </p:nvPicPr>
         <p:blipFill rotWithShape="1">
-          <a:blip xmlns:r="http://schemas.openxmlformats.org/officeDocument/2006/relationships" xmlns:a="http://schemas.openxmlformats.org/drawingml/2006/main" r:embed="Ra9d25cd3cb9a4d0e">
+          <a:blip xmlns:r="http://schemas.openxmlformats.org/officeDocument/2006/relationships" xmlns:a="http://schemas.openxmlformats.org/drawingml/2006/main" r:embed="Rafd148678ebf48a4">
             <a:alphaModFix amt="28000"/>
           </a:blip>
           <a:stretch xmlns:a="http://schemas.openxmlformats.org/drawingml/2006/main"/>
@@ -3016,7 +3016,7 @@
           <p:nvPr/>
         </p:nvPicPr>
         <p:blipFill rotWithShape="1">
-          <a:blip xmlns:r="http://schemas.openxmlformats.org/officeDocument/2006/relationships" xmlns:a="http://schemas.openxmlformats.org/drawingml/2006/main" r:embed="R146948d11db34781">
+          <a:blip xmlns:r="http://schemas.openxmlformats.org/officeDocument/2006/relationships" xmlns:a="http://schemas.openxmlformats.org/drawingml/2006/main" r:embed="R167f2ade743a4fc8">
             <a:alphaModFix amt="28000"/>
           </a:blip>
           <a:stretch xmlns:a="http://schemas.openxmlformats.org/drawingml/2006/main"/>
@@ -3130,7 +3130,7 @@
           <p:nvPr/>
         </p:nvPicPr>
         <p:blipFill rotWithShape="1">
-          <a:blip xmlns:r="http://schemas.openxmlformats.org/officeDocument/2006/relationships" xmlns:a="http://schemas.openxmlformats.org/drawingml/2006/main" r:embed="Rf03f01fa4cf045cd">
+          <a:blip xmlns:r="http://schemas.openxmlformats.org/officeDocument/2006/relationships" xmlns:a="http://schemas.openxmlformats.org/drawingml/2006/main" r:embed="Rc814032f7dba47d0">
             <a:alphaModFix amt="28000"/>
           </a:blip>
           <a:stretch xmlns:a="http://schemas.openxmlformats.org/drawingml/2006/main"/>
@@ -3457,7 +3457,7 @@
           <p:nvPr/>
         </p:nvPicPr>
         <p:blipFill rotWithShape="1">
-          <a:blip xmlns:r="http://schemas.openxmlformats.org/officeDocument/2006/relationships" xmlns:a="http://schemas.openxmlformats.org/drawingml/2006/main" r:embed="R6b7b4c4161534c5f">
+          <a:blip xmlns:r="http://schemas.openxmlformats.org/officeDocument/2006/relationships" xmlns:a="http://schemas.openxmlformats.org/drawingml/2006/main" r:embed="Rc79ab27d4ddf43c2">
             <a:alphaModFix amt="28000"/>
           </a:blip>
           <a:stretch xmlns:a="http://schemas.openxmlformats.org/drawingml/2006/main"/>
@@ -3745,7 +3745,7 @@
           <p:nvPr/>
         </p:nvPicPr>
         <p:blipFill rotWithShape="1">
-          <a:blip xmlns:r="http://schemas.openxmlformats.org/officeDocument/2006/relationships" xmlns:a="http://schemas.openxmlformats.org/drawingml/2006/main" r:embed="Re5d27811e9e747ea">
+          <a:blip xmlns:r="http://schemas.openxmlformats.org/officeDocument/2006/relationships" xmlns:a="http://schemas.openxmlformats.org/drawingml/2006/main" r:embed="R033a605392b64443">
             <a:alphaModFix amt="28000"/>
           </a:blip>
           <a:stretch xmlns:a="http://schemas.openxmlformats.org/drawingml/2006/main"/>
@@ -3982,17 +3982,17 @@
   </p:cSld>
   <p:clrMap bg1="lt1" tx1="dk1" bg2="lt2" tx2="dk2" accent1="accent1" accent2="accent2" accent3="accent3" accent4="accent4" accent5="accent5" accent6="accent6" hlink="hlink" folHlink="folHlink"/>
   <p:sldLayoutIdLst>
-    <p:sldLayoutId xmlns:r="http://schemas.openxmlformats.org/officeDocument/2006/relationships" id="2147483649" r:id="R1c0bdc59f3494879"/>
-    <p:sldLayoutId xmlns:r="http://schemas.openxmlformats.org/officeDocument/2006/relationships" id="2147483650" r:id="R320d4132cd2d47d6"/>
-    <p:sldLayoutId xmlns:r="http://schemas.openxmlformats.org/officeDocument/2006/relationships" id="2147483651" r:id="Raa8622b3df1140d9"/>
-    <p:sldLayoutId xmlns:r="http://schemas.openxmlformats.org/officeDocument/2006/relationships" id="2147483652" r:id="Redd1fe57e4dc4a9b"/>
-    <p:sldLayoutId xmlns:r="http://schemas.openxmlformats.org/officeDocument/2006/relationships" id="2147483653" r:id="Rccc3fa261d7c402f"/>
-    <p:sldLayoutId xmlns:r="http://schemas.openxmlformats.org/officeDocument/2006/relationships" id="2147483654" r:id="R66f8609f453b4add"/>
-    <p:sldLayoutId xmlns:r="http://schemas.openxmlformats.org/officeDocument/2006/relationships" id="2147483655" r:id="R51127d00352c4dce"/>
-    <p:sldLayoutId xmlns:r="http://schemas.openxmlformats.org/officeDocument/2006/relationships" id="2147483656" r:id="R62c83e1b367e44dc"/>
-    <p:sldLayoutId xmlns:r="http://schemas.openxmlformats.org/officeDocument/2006/relationships" id="2147483657" r:id="R77ddb7ac439e4ea0"/>
-    <p:sldLayoutId xmlns:r="http://schemas.openxmlformats.org/officeDocument/2006/relationships" id="2147483658" r:id="Rff82dffbc83542c8"/>
-    <p:sldLayoutId xmlns:r="http://schemas.openxmlformats.org/officeDocument/2006/relationships" id="2147483659" r:id="R0fa2abb16aac4ffe"/>
+    <p:sldLayoutId xmlns:r="http://schemas.openxmlformats.org/officeDocument/2006/relationships" id="2147483649" r:id="Rb3dbd0a04d6e4905"/>
+    <p:sldLayoutId xmlns:r="http://schemas.openxmlformats.org/officeDocument/2006/relationships" id="2147483650" r:id="R6d734e67ddd04dbd"/>
+    <p:sldLayoutId xmlns:r="http://schemas.openxmlformats.org/officeDocument/2006/relationships" id="2147483651" r:id="R8c9a9380dc33449b"/>
+    <p:sldLayoutId xmlns:r="http://schemas.openxmlformats.org/officeDocument/2006/relationships" id="2147483652" r:id="R73e1814e18354064"/>
+    <p:sldLayoutId xmlns:r="http://schemas.openxmlformats.org/officeDocument/2006/relationships" id="2147483653" r:id="Ra7a0625af23447a3"/>
+    <p:sldLayoutId xmlns:r="http://schemas.openxmlformats.org/officeDocument/2006/relationships" id="2147483654" r:id="R31183ee55ae64874"/>
+    <p:sldLayoutId xmlns:r="http://schemas.openxmlformats.org/officeDocument/2006/relationships" id="2147483655" r:id="R357fcce71e844039"/>
+    <p:sldLayoutId xmlns:r="http://schemas.openxmlformats.org/officeDocument/2006/relationships" id="2147483656" r:id="Rc99a7f44adc143aa"/>
+    <p:sldLayoutId xmlns:r="http://schemas.openxmlformats.org/officeDocument/2006/relationships" id="2147483657" r:id="Rfa01b03709094b55"/>
+    <p:sldLayoutId xmlns:r="http://schemas.openxmlformats.org/officeDocument/2006/relationships" id="2147483658" r:id="R3080a8d8b0e64a9e"/>
+    <p:sldLayoutId xmlns:r="http://schemas.openxmlformats.org/officeDocument/2006/relationships" id="2147483659" r:id="R709a728dd8d44e5a"/>
   </p:sldLayoutIdLst>
   <p:hf hdr="0" ftr="0" dt="0"/>
   <p:txStyles>

</xml_diff>

<commit_message>
fix: colour keywords orange in every worksheet and concept sheet
Example code in unchanged worksheets and all concept sheets was inherited
from earlier builds with keywords in the old blue. A recolouring pass now
turns those keywords orange, splits plain runs such as "import random",
and returns keywords inside English notes (for example "1 and 6 can both
be rolled") to black. import, None, break and continue join the keyword
set; English "anything else" is no longer coloured.

Co-Authored-By: Claude Opus 5.5 <noreply@anthropic.com>
</commit_message>
<xml_diff>
--- a/Mapped Curriculum Lessons/Grade 6/Lesson 01 - Hello Python!/Hello Python! - Slides.pptx
+++ b/Mapped Curriculum Lessons/Grade 6/Lesson 01 - Hello Python!/Hello Python! - Slides.pptx
@@ -2,28 +2,28 @@
 <file path=ppt/presentation.xml><?xml version="1.0" encoding="utf-8"?>
 <p:presentation xmlns:p="http://schemas.openxmlformats.org/presentationml/2006/main" embedTrueTypeFonts="1" saveSubsetFonts="0">
   <p:sldMasterIdLst>
-    <p:sldMasterId xmlns:r="http://schemas.openxmlformats.org/officeDocument/2006/relationships" id="2147483648" r:id="Rdc7d04087ff34087"/>
+    <p:sldMasterId xmlns:r="http://schemas.openxmlformats.org/officeDocument/2006/relationships" id="2147483648" r:id="Rd87b5d11f0e848bb"/>
   </p:sldMasterIdLst>
   <p:notesMasterIdLst>
-    <p:notesMasterId xmlns:r="http://schemas.openxmlformats.org/officeDocument/2006/relationships" r:id="R8fae1f3662694304"/>
+    <p:notesMasterId xmlns:r="http://schemas.openxmlformats.org/officeDocument/2006/relationships" r:id="R1f41a9f576064002"/>
   </p:notesMasterIdLst>
   <p:sldIdLst>
-    <p:sldId xmlns:r="http://schemas.openxmlformats.org/officeDocument/2006/relationships" id="256" r:id="R6ba6ddb55452494f"/>
-    <p:sldId xmlns:r="http://schemas.openxmlformats.org/officeDocument/2006/relationships" id="257" r:id="Ree03896ffd50440f"/>
-    <p:sldId xmlns:r="http://schemas.openxmlformats.org/officeDocument/2006/relationships" id="258" r:id="R1af86deb54c04f00"/>
-    <p:sldId xmlns:r="http://schemas.openxmlformats.org/officeDocument/2006/relationships" id="259" r:id="R4f79ff7b1b884161"/>
-    <p:sldId xmlns:r="http://schemas.openxmlformats.org/officeDocument/2006/relationships" id="260" r:id="R62ce80462e8749a7"/>
-    <p:sldId xmlns:r="http://schemas.openxmlformats.org/officeDocument/2006/relationships" id="261" r:id="R3b66a536e3fa4652"/>
-    <p:sldId xmlns:r="http://schemas.openxmlformats.org/officeDocument/2006/relationships" id="262" r:id="Rb691c8a34ed1476d"/>
-    <p:sldId xmlns:r="http://schemas.openxmlformats.org/officeDocument/2006/relationships" id="263" r:id="R2519f9e3ea5044fe"/>
-    <p:sldId xmlns:r="http://schemas.openxmlformats.org/officeDocument/2006/relationships" id="264" r:id="Rdb535a74e0a94127"/>
+    <p:sldId xmlns:r="http://schemas.openxmlformats.org/officeDocument/2006/relationships" id="256" r:id="R5cfed9bdeaeb4aea"/>
+    <p:sldId xmlns:r="http://schemas.openxmlformats.org/officeDocument/2006/relationships" id="257" r:id="R82efc31064624794"/>
+    <p:sldId xmlns:r="http://schemas.openxmlformats.org/officeDocument/2006/relationships" id="258" r:id="Ra6738e1c2302428c"/>
+    <p:sldId xmlns:r="http://schemas.openxmlformats.org/officeDocument/2006/relationships" id="259" r:id="R310fb602d98a441d"/>
+    <p:sldId xmlns:r="http://schemas.openxmlformats.org/officeDocument/2006/relationships" id="260" r:id="R63a5c2483af94922"/>
+    <p:sldId xmlns:r="http://schemas.openxmlformats.org/officeDocument/2006/relationships" id="261" r:id="Re3dbb9aa13a04cf7"/>
+    <p:sldId xmlns:r="http://schemas.openxmlformats.org/officeDocument/2006/relationships" id="262" r:id="R5f1284d5abc74cb9"/>
+    <p:sldId xmlns:r="http://schemas.openxmlformats.org/officeDocument/2006/relationships" id="263" r:id="R2ff5316e9f1e48c6"/>
+    <p:sldId xmlns:r="http://schemas.openxmlformats.org/officeDocument/2006/relationships" id="264" r:id="Rbba99ffeef7645d5"/>
   </p:sldIdLst>
   <p:sldSz cx="12192000" cy="6858000"/>
   <p:notesSz cx="6858000" cy="9144000"/>
   <p:embeddedFontLst>
     <p:embeddedFont>
       <p:font typeface="JetBrains Mono"/>
-      <p:regular xmlns:r="http://schemas.openxmlformats.org/officeDocument/2006/relationships" r:id="R6212d3e028b94548"/>
+      <p:regular xmlns:r="http://schemas.openxmlformats.org/officeDocument/2006/relationships" r:id="Rf8b7042549dc4891"/>
     </p:embeddedFont>
   </p:embeddedFontLst>
 </p:presentation>
@@ -1071,7 +1071,7 @@
           <p:nvPr/>
         </p:nvPicPr>
         <p:blipFill rotWithShape="1">
-          <a:blip xmlns:r="http://schemas.openxmlformats.org/officeDocument/2006/relationships" xmlns:a="http://schemas.openxmlformats.org/drawingml/2006/main" r:embed="R1ece304c4b1d4c07"/>
+          <a:blip xmlns:r="http://schemas.openxmlformats.org/officeDocument/2006/relationships" xmlns:a="http://schemas.openxmlformats.org/drawingml/2006/main" r:embed="Rfdb7530ed2414b04"/>
           <a:stretch xmlns:a="http://schemas.openxmlformats.org/drawingml/2006/main"/>
         </p:blipFill>
         <p:spPr>
@@ -1451,7 +1451,7 @@
           <p:nvPr/>
         </p:nvPicPr>
         <p:blipFill rotWithShape="1">
-          <a:blip xmlns:r="http://schemas.openxmlformats.org/officeDocument/2006/relationships" xmlns:a="http://schemas.openxmlformats.org/drawingml/2006/main" r:embed="Raaf39e412f624b1e">
+          <a:blip xmlns:r="http://schemas.openxmlformats.org/officeDocument/2006/relationships" xmlns:a="http://schemas.openxmlformats.org/drawingml/2006/main" r:embed="R98b24695eefa4128">
             <a:alphaModFix amt="28000"/>
           </a:blip>
           <a:stretch xmlns:a="http://schemas.openxmlformats.org/drawingml/2006/main"/>
@@ -1664,7 +1664,7 @@
           <p:nvPr/>
         </p:nvPicPr>
         <p:blipFill rotWithShape="1">
-          <a:blip xmlns:r="http://schemas.openxmlformats.org/officeDocument/2006/relationships" xmlns:a="http://schemas.openxmlformats.org/drawingml/2006/main" r:embed="R61121419c5fd4a71">
+          <a:blip xmlns:r="http://schemas.openxmlformats.org/officeDocument/2006/relationships" xmlns:a="http://schemas.openxmlformats.org/drawingml/2006/main" r:embed="R141d714083334d08">
             <a:alphaModFix amt="28000"/>
           </a:blip>
           <a:stretch xmlns:a="http://schemas.openxmlformats.org/drawingml/2006/main"/>
@@ -1899,7 +1899,7 @@
           <p:nvPr/>
         </p:nvPicPr>
         <p:blipFill rotWithShape="1">
-          <a:blip xmlns:r="http://schemas.openxmlformats.org/officeDocument/2006/relationships" xmlns:a="http://schemas.openxmlformats.org/drawingml/2006/main" r:embed="Rbb99d5f99df14d2c">
+          <a:blip xmlns:r="http://schemas.openxmlformats.org/officeDocument/2006/relationships" xmlns:a="http://schemas.openxmlformats.org/drawingml/2006/main" r:embed="R9c7d8330dd6f4f86">
             <a:alphaModFix amt="28000"/>
           </a:blip>
           <a:stretch xmlns:a="http://schemas.openxmlformats.org/drawingml/2006/main"/>
@@ -2176,7 +2176,7 @@
           <p:nvPr/>
         </p:nvPicPr>
         <p:blipFill rotWithShape="1">
-          <a:blip xmlns:r="http://schemas.openxmlformats.org/officeDocument/2006/relationships" xmlns:a="http://schemas.openxmlformats.org/drawingml/2006/main" r:embed="R86e60a1420ab458e">
+          <a:blip xmlns:r="http://schemas.openxmlformats.org/officeDocument/2006/relationships" xmlns:a="http://schemas.openxmlformats.org/drawingml/2006/main" r:embed="R7219a31d35414329">
             <a:alphaModFix amt="28000"/>
           </a:blip>
           <a:stretch xmlns:a="http://schemas.openxmlformats.org/drawingml/2006/main"/>
@@ -2451,7 +2451,7 @@
           <p:nvPr/>
         </p:nvPicPr>
         <p:blipFill rotWithShape="1">
-          <a:blip xmlns:r="http://schemas.openxmlformats.org/officeDocument/2006/relationships" xmlns:a="http://schemas.openxmlformats.org/drawingml/2006/main" r:embed="Ra7370ab2f0f44d56">
+          <a:blip xmlns:r="http://schemas.openxmlformats.org/officeDocument/2006/relationships" xmlns:a="http://schemas.openxmlformats.org/drawingml/2006/main" r:embed="Rfc89c794efcf4325">
             <a:alphaModFix amt="28000"/>
           </a:blip>
           <a:stretch xmlns:a="http://schemas.openxmlformats.org/drawingml/2006/main"/>
@@ -2875,7 +2875,7 @@
           <p:nvPr/>
         </p:nvPicPr>
         <p:blipFill rotWithShape="1">
-          <a:blip xmlns:r="http://schemas.openxmlformats.org/officeDocument/2006/relationships" xmlns:a="http://schemas.openxmlformats.org/drawingml/2006/main" r:embed="Rafd148678ebf48a4">
+          <a:blip xmlns:r="http://schemas.openxmlformats.org/officeDocument/2006/relationships" xmlns:a="http://schemas.openxmlformats.org/drawingml/2006/main" r:embed="Rc263eddd067d470d">
             <a:alphaModFix amt="28000"/>
           </a:blip>
           <a:stretch xmlns:a="http://schemas.openxmlformats.org/drawingml/2006/main"/>
@@ -3016,7 +3016,7 @@
           <p:nvPr/>
         </p:nvPicPr>
         <p:blipFill rotWithShape="1">
-          <a:blip xmlns:r="http://schemas.openxmlformats.org/officeDocument/2006/relationships" xmlns:a="http://schemas.openxmlformats.org/drawingml/2006/main" r:embed="R167f2ade743a4fc8">
+          <a:blip xmlns:r="http://schemas.openxmlformats.org/officeDocument/2006/relationships" xmlns:a="http://schemas.openxmlformats.org/drawingml/2006/main" r:embed="Re16d9a1bf41e4793">
             <a:alphaModFix amt="28000"/>
           </a:blip>
           <a:stretch xmlns:a="http://schemas.openxmlformats.org/drawingml/2006/main"/>
@@ -3130,7 +3130,7 @@
           <p:nvPr/>
         </p:nvPicPr>
         <p:blipFill rotWithShape="1">
-          <a:blip xmlns:r="http://schemas.openxmlformats.org/officeDocument/2006/relationships" xmlns:a="http://schemas.openxmlformats.org/drawingml/2006/main" r:embed="Rc814032f7dba47d0">
+          <a:blip xmlns:r="http://schemas.openxmlformats.org/officeDocument/2006/relationships" xmlns:a="http://schemas.openxmlformats.org/drawingml/2006/main" r:embed="R1472601ac4004869">
             <a:alphaModFix amt="28000"/>
           </a:blip>
           <a:stretch xmlns:a="http://schemas.openxmlformats.org/drawingml/2006/main"/>
@@ -3457,7 +3457,7 @@
           <p:nvPr/>
         </p:nvPicPr>
         <p:blipFill rotWithShape="1">
-          <a:blip xmlns:r="http://schemas.openxmlformats.org/officeDocument/2006/relationships" xmlns:a="http://schemas.openxmlformats.org/drawingml/2006/main" r:embed="Rc79ab27d4ddf43c2">
+          <a:blip xmlns:r="http://schemas.openxmlformats.org/officeDocument/2006/relationships" xmlns:a="http://schemas.openxmlformats.org/drawingml/2006/main" r:embed="Rf38a33c75c8c4bc8">
             <a:alphaModFix amt="28000"/>
           </a:blip>
           <a:stretch xmlns:a="http://schemas.openxmlformats.org/drawingml/2006/main"/>
@@ -3745,7 +3745,7 @@
           <p:nvPr/>
         </p:nvPicPr>
         <p:blipFill rotWithShape="1">
-          <a:blip xmlns:r="http://schemas.openxmlformats.org/officeDocument/2006/relationships" xmlns:a="http://schemas.openxmlformats.org/drawingml/2006/main" r:embed="R033a605392b64443">
+          <a:blip xmlns:r="http://schemas.openxmlformats.org/officeDocument/2006/relationships" xmlns:a="http://schemas.openxmlformats.org/drawingml/2006/main" r:embed="Rd02d69e7b5b4421a">
             <a:alphaModFix amt="28000"/>
           </a:blip>
           <a:stretch xmlns:a="http://schemas.openxmlformats.org/drawingml/2006/main"/>
@@ -3982,17 +3982,17 @@
   </p:cSld>
   <p:clrMap bg1="lt1" tx1="dk1" bg2="lt2" tx2="dk2" accent1="accent1" accent2="accent2" accent3="accent3" accent4="accent4" accent5="accent5" accent6="accent6" hlink="hlink" folHlink="folHlink"/>
   <p:sldLayoutIdLst>
-    <p:sldLayoutId xmlns:r="http://schemas.openxmlformats.org/officeDocument/2006/relationships" id="2147483649" r:id="Rb3dbd0a04d6e4905"/>
-    <p:sldLayoutId xmlns:r="http://schemas.openxmlformats.org/officeDocument/2006/relationships" id="2147483650" r:id="R6d734e67ddd04dbd"/>
-    <p:sldLayoutId xmlns:r="http://schemas.openxmlformats.org/officeDocument/2006/relationships" id="2147483651" r:id="R8c9a9380dc33449b"/>
-    <p:sldLayoutId xmlns:r="http://schemas.openxmlformats.org/officeDocument/2006/relationships" id="2147483652" r:id="R73e1814e18354064"/>
-    <p:sldLayoutId xmlns:r="http://schemas.openxmlformats.org/officeDocument/2006/relationships" id="2147483653" r:id="Ra7a0625af23447a3"/>
-    <p:sldLayoutId xmlns:r="http://schemas.openxmlformats.org/officeDocument/2006/relationships" id="2147483654" r:id="R31183ee55ae64874"/>
-    <p:sldLayoutId xmlns:r="http://schemas.openxmlformats.org/officeDocument/2006/relationships" id="2147483655" r:id="R357fcce71e844039"/>
-    <p:sldLayoutId xmlns:r="http://schemas.openxmlformats.org/officeDocument/2006/relationships" id="2147483656" r:id="Rc99a7f44adc143aa"/>
-    <p:sldLayoutId xmlns:r="http://schemas.openxmlformats.org/officeDocument/2006/relationships" id="2147483657" r:id="Rfa01b03709094b55"/>
-    <p:sldLayoutId xmlns:r="http://schemas.openxmlformats.org/officeDocument/2006/relationships" id="2147483658" r:id="R3080a8d8b0e64a9e"/>
-    <p:sldLayoutId xmlns:r="http://schemas.openxmlformats.org/officeDocument/2006/relationships" id="2147483659" r:id="R709a728dd8d44e5a"/>
+    <p:sldLayoutId xmlns:r="http://schemas.openxmlformats.org/officeDocument/2006/relationships" id="2147483649" r:id="R769c39d7cad6402a"/>
+    <p:sldLayoutId xmlns:r="http://schemas.openxmlformats.org/officeDocument/2006/relationships" id="2147483650" r:id="R93c8942cfe64415b"/>
+    <p:sldLayoutId xmlns:r="http://schemas.openxmlformats.org/officeDocument/2006/relationships" id="2147483651" r:id="R52df124207c0433f"/>
+    <p:sldLayoutId xmlns:r="http://schemas.openxmlformats.org/officeDocument/2006/relationships" id="2147483652" r:id="R5d1bf95330164a35"/>
+    <p:sldLayoutId xmlns:r="http://schemas.openxmlformats.org/officeDocument/2006/relationships" id="2147483653" r:id="Rf989f911fb1b408b"/>
+    <p:sldLayoutId xmlns:r="http://schemas.openxmlformats.org/officeDocument/2006/relationships" id="2147483654" r:id="R3dadd0296adc4b00"/>
+    <p:sldLayoutId xmlns:r="http://schemas.openxmlformats.org/officeDocument/2006/relationships" id="2147483655" r:id="Rc149dc3b90dc4977"/>
+    <p:sldLayoutId xmlns:r="http://schemas.openxmlformats.org/officeDocument/2006/relationships" id="2147483656" r:id="R899b7716fa3f4ac9"/>
+    <p:sldLayoutId xmlns:r="http://schemas.openxmlformats.org/officeDocument/2006/relationships" id="2147483657" r:id="R36a3609c18664d98"/>
+    <p:sldLayoutId xmlns:r="http://schemas.openxmlformats.org/officeDocument/2006/relationships" id="2147483658" r:id="Rf027d6339d50413a"/>
+    <p:sldLayoutId xmlns:r="http://schemas.openxmlformats.org/officeDocument/2006/relationships" id="2147483659" r:id="R82490bf08a014632"/>
   </p:sldLayoutIdLst>
   <p:hf hdr="0" ftr="0" dt="0"/>
   <p:txStyles>

</xml_diff>

<commit_message>
fix: keep slide code indentation visible in PowerPoint
PowerPoint's slide editor collapsed runs that held only spaces, so lines
such as "    if" and "        print" lost their indentation on the slide
while thumbnails showed it. Leading and inter-token spaces now travel inside
a neighbouring JetBrains Mono run.

Co-Authored-By: Claude Opus 5.5 <noreply@anthropic.com>
</commit_message>
<xml_diff>
--- a/Mapped Curriculum Lessons/Grade 6/Lesson 01 - Hello Python!/Hello Python! - Slides.pptx
+++ b/Mapped Curriculum Lessons/Grade 6/Lesson 01 - Hello Python!/Hello Python! - Slides.pptx
@@ -2,28 +2,28 @@
 <file path=ppt/presentation.xml><?xml version="1.0" encoding="utf-8"?>
 <p:presentation xmlns:p="http://schemas.openxmlformats.org/presentationml/2006/main" embedTrueTypeFonts="1" saveSubsetFonts="0">
   <p:sldMasterIdLst>
-    <p:sldMasterId xmlns:r="http://schemas.openxmlformats.org/officeDocument/2006/relationships" id="2147483648" r:id="Rd87b5d11f0e848bb"/>
+    <p:sldMasterId xmlns:r="http://schemas.openxmlformats.org/officeDocument/2006/relationships" id="2147483648" r:id="R6fecc763244a4ac9"/>
   </p:sldMasterIdLst>
   <p:notesMasterIdLst>
-    <p:notesMasterId xmlns:r="http://schemas.openxmlformats.org/officeDocument/2006/relationships" r:id="R1f41a9f576064002"/>
+    <p:notesMasterId xmlns:r="http://schemas.openxmlformats.org/officeDocument/2006/relationships" r:id="Rade4444b28ce4b3c"/>
   </p:notesMasterIdLst>
   <p:sldIdLst>
-    <p:sldId xmlns:r="http://schemas.openxmlformats.org/officeDocument/2006/relationships" id="256" r:id="R5cfed9bdeaeb4aea"/>
-    <p:sldId xmlns:r="http://schemas.openxmlformats.org/officeDocument/2006/relationships" id="257" r:id="R82efc31064624794"/>
-    <p:sldId xmlns:r="http://schemas.openxmlformats.org/officeDocument/2006/relationships" id="258" r:id="Ra6738e1c2302428c"/>
-    <p:sldId xmlns:r="http://schemas.openxmlformats.org/officeDocument/2006/relationships" id="259" r:id="R310fb602d98a441d"/>
-    <p:sldId xmlns:r="http://schemas.openxmlformats.org/officeDocument/2006/relationships" id="260" r:id="R63a5c2483af94922"/>
-    <p:sldId xmlns:r="http://schemas.openxmlformats.org/officeDocument/2006/relationships" id="261" r:id="Re3dbb9aa13a04cf7"/>
-    <p:sldId xmlns:r="http://schemas.openxmlformats.org/officeDocument/2006/relationships" id="262" r:id="R5f1284d5abc74cb9"/>
-    <p:sldId xmlns:r="http://schemas.openxmlformats.org/officeDocument/2006/relationships" id="263" r:id="R2ff5316e9f1e48c6"/>
-    <p:sldId xmlns:r="http://schemas.openxmlformats.org/officeDocument/2006/relationships" id="264" r:id="Rbba99ffeef7645d5"/>
+    <p:sldId xmlns:r="http://schemas.openxmlformats.org/officeDocument/2006/relationships" id="256" r:id="R4675aaf0e9684683"/>
+    <p:sldId xmlns:r="http://schemas.openxmlformats.org/officeDocument/2006/relationships" id="257" r:id="Rb9b03d64a2fa4356"/>
+    <p:sldId xmlns:r="http://schemas.openxmlformats.org/officeDocument/2006/relationships" id="258" r:id="Rb7ea8beadce94f15"/>
+    <p:sldId xmlns:r="http://schemas.openxmlformats.org/officeDocument/2006/relationships" id="259" r:id="R1c7d4a5409384dbd"/>
+    <p:sldId xmlns:r="http://schemas.openxmlformats.org/officeDocument/2006/relationships" id="260" r:id="R3eda4dfaea774639"/>
+    <p:sldId xmlns:r="http://schemas.openxmlformats.org/officeDocument/2006/relationships" id="261" r:id="R5f2c5382858c41e1"/>
+    <p:sldId xmlns:r="http://schemas.openxmlformats.org/officeDocument/2006/relationships" id="262" r:id="R339b7bf1489a4264"/>
+    <p:sldId xmlns:r="http://schemas.openxmlformats.org/officeDocument/2006/relationships" id="263" r:id="R728c846d6b514386"/>
+    <p:sldId xmlns:r="http://schemas.openxmlformats.org/officeDocument/2006/relationships" id="264" r:id="Rec61c0e6fa0a4cdb"/>
   </p:sldIdLst>
   <p:sldSz cx="12192000" cy="6858000"/>
   <p:notesSz cx="6858000" cy="9144000"/>
   <p:embeddedFontLst>
     <p:embeddedFont>
       <p:font typeface="JetBrains Mono"/>
-      <p:regular xmlns:r="http://schemas.openxmlformats.org/officeDocument/2006/relationships" r:id="Rf8b7042549dc4891"/>
+      <p:regular xmlns:r="http://schemas.openxmlformats.org/officeDocument/2006/relationships" r:id="R3aa0f581ac374228"/>
     </p:embeddedFont>
   </p:embeddedFontLst>
 </p:presentation>
@@ -1071,7 +1071,7 @@
           <p:nvPr/>
         </p:nvPicPr>
         <p:blipFill rotWithShape="1">
-          <a:blip xmlns:r="http://schemas.openxmlformats.org/officeDocument/2006/relationships" xmlns:a="http://schemas.openxmlformats.org/drawingml/2006/main" r:embed="Rfdb7530ed2414b04"/>
+          <a:blip xmlns:r="http://schemas.openxmlformats.org/officeDocument/2006/relationships" xmlns:a="http://schemas.openxmlformats.org/drawingml/2006/main" r:embed="R1d8a5d7b2ca04843"/>
           <a:stretch xmlns:a="http://schemas.openxmlformats.org/drawingml/2006/main"/>
         </p:blipFill>
         <p:spPr>
@@ -1451,7 +1451,7 @@
           <p:nvPr/>
         </p:nvPicPr>
         <p:blipFill rotWithShape="1">
-          <a:blip xmlns:r="http://schemas.openxmlformats.org/officeDocument/2006/relationships" xmlns:a="http://schemas.openxmlformats.org/drawingml/2006/main" r:embed="R98b24695eefa4128">
+          <a:blip xmlns:r="http://schemas.openxmlformats.org/officeDocument/2006/relationships" xmlns:a="http://schemas.openxmlformats.org/drawingml/2006/main" r:embed="Rdc5105b40224467d">
             <a:alphaModFix amt="28000"/>
           </a:blip>
           <a:stretch xmlns:a="http://schemas.openxmlformats.org/drawingml/2006/main"/>
@@ -1664,7 +1664,7 @@
           <p:nvPr/>
         </p:nvPicPr>
         <p:blipFill rotWithShape="1">
-          <a:blip xmlns:r="http://schemas.openxmlformats.org/officeDocument/2006/relationships" xmlns:a="http://schemas.openxmlformats.org/drawingml/2006/main" r:embed="R141d714083334d08">
+          <a:blip xmlns:r="http://schemas.openxmlformats.org/officeDocument/2006/relationships" xmlns:a="http://schemas.openxmlformats.org/drawingml/2006/main" r:embed="R039491bc7a094f90">
             <a:alphaModFix amt="28000"/>
           </a:blip>
           <a:stretch xmlns:a="http://schemas.openxmlformats.org/drawingml/2006/main"/>
@@ -1899,7 +1899,7 @@
           <p:nvPr/>
         </p:nvPicPr>
         <p:blipFill rotWithShape="1">
-          <a:blip xmlns:r="http://schemas.openxmlformats.org/officeDocument/2006/relationships" xmlns:a="http://schemas.openxmlformats.org/drawingml/2006/main" r:embed="R9c7d8330dd6f4f86">
+          <a:blip xmlns:r="http://schemas.openxmlformats.org/officeDocument/2006/relationships" xmlns:a="http://schemas.openxmlformats.org/drawingml/2006/main" r:embed="R52da0ba38e544304">
             <a:alphaModFix amt="28000"/>
           </a:blip>
           <a:stretch xmlns:a="http://schemas.openxmlformats.org/drawingml/2006/main"/>
@@ -2176,7 +2176,7 @@
           <p:nvPr/>
         </p:nvPicPr>
         <p:blipFill rotWithShape="1">
-          <a:blip xmlns:r="http://schemas.openxmlformats.org/officeDocument/2006/relationships" xmlns:a="http://schemas.openxmlformats.org/drawingml/2006/main" r:embed="R7219a31d35414329">
+          <a:blip xmlns:r="http://schemas.openxmlformats.org/officeDocument/2006/relationships" xmlns:a="http://schemas.openxmlformats.org/drawingml/2006/main" r:embed="Rb395674e32ec43c9">
             <a:alphaModFix amt="28000"/>
           </a:blip>
           <a:stretch xmlns:a="http://schemas.openxmlformats.org/drawingml/2006/main"/>
@@ -2451,7 +2451,7 @@
           <p:nvPr/>
         </p:nvPicPr>
         <p:blipFill rotWithShape="1">
-          <a:blip xmlns:r="http://schemas.openxmlformats.org/officeDocument/2006/relationships" xmlns:a="http://schemas.openxmlformats.org/drawingml/2006/main" r:embed="Rfc89c794efcf4325">
+          <a:blip xmlns:r="http://schemas.openxmlformats.org/officeDocument/2006/relationships" xmlns:a="http://schemas.openxmlformats.org/drawingml/2006/main" r:embed="Rf51843f24939421b">
             <a:alphaModFix amt="28000"/>
           </a:blip>
           <a:stretch xmlns:a="http://schemas.openxmlformats.org/drawingml/2006/main"/>
@@ -2875,7 +2875,7 @@
           <p:nvPr/>
         </p:nvPicPr>
         <p:blipFill rotWithShape="1">
-          <a:blip xmlns:r="http://schemas.openxmlformats.org/officeDocument/2006/relationships" xmlns:a="http://schemas.openxmlformats.org/drawingml/2006/main" r:embed="Rc263eddd067d470d">
+          <a:blip xmlns:r="http://schemas.openxmlformats.org/officeDocument/2006/relationships" xmlns:a="http://schemas.openxmlformats.org/drawingml/2006/main" r:embed="R1fe457012b2e462e">
             <a:alphaModFix amt="28000"/>
           </a:blip>
           <a:stretch xmlns:a="http://schemas.openxmlformats.org/drawingml/2006/main"/>
@@ -3016,7 +3016,7 @@
           <p:nvPr/>
         </p:nvPicPr>
         <p:blipFill rotWithShape="1">
-          <a:blip xmlns:r="http://schemas.openxmlformats.org/officeDocument/2006/relationships" xmlns:a="http://schemas.openxmlformats.org/drawingml/2006/main" r:embed="Re16d9a1bf41e4793">
+          <a:blip xmlns:r="http://schemas.openxmlformats.org/officeDocument/2006/relationships" xmlns:a="http://schemas.openxmlformats.org/drawingml/2006/main" r:embed="Rcc87ef5635de4b74">
             <a:alphaModFix amt="28000"/>
           </a:blip>
           <a:stretch xmlns:a="http://schemas.openxmlformats.org/drawingml/2006/main"/>
@@ -3130,7 +3130,7 @@
           <p:nvPr/>
         </p:nvPicPr>
         <p:blipFill rotWithShape="1">
-          <a:blip xmlns:r="http://schemas.openxmlformats.org/officeDocument/2006/relationships" xmlns:a="http://schemas.openxmlformats.org/drawingml/2006/main" r:embed="R1472601ac4004869">
+          <a:blip xmlns:r="http://schemas.openxmlformats.org/officeDocument/2006/relationships" xmlns:a="http://schemas.openxmlformats.org/drawingml/2006/main" r:embed="Rf8cc01cd75a64a18">
             <a:alphaModFix amt="28000"/>
           </a:blip>
           <a:stretch xmlns:a="http://schemas.openxmlformats.org/drawingml/2006/main"/>
@@ -3457,7 +3457,7 @@
           <p:nvPr/>
         </p:nvPicPr>
         <p:blipFill rotWithShape="1">
-          <a:blip xmlns:r="http://schemas.openxmlformats.org/officeDocument/2006/relationships" xmlns:a="http://schemas.openxmlformats.org/drawingml/2006/main" r:embed="Rf38a33c75c8c4bc8">
+          <a:blip xmlns:r="http://schemas.openxmlformats.org/officeDocument/2006/relationships" xmlns:a="http://schemas.openxmlformats.org/drawingml/2006/main" r:embed="R994a2c5efdc44b25">
             <a:alphaModFix amt="28000"/>
           </a:blip>
           <a:stretch xmlns:a="http://schemas.openxmlformats.org/drawingml/2006/main"/>
@@ -3745,7 +3745,7 @@
           <p:nvPr/>
         </p:nvPicPr>
         <p:blipFill rotWithShape="1">
-          <a:blip xmlns:r="http://schemas.openxmlformats.org/officeDocument/2006/relationships" xmlns:a="http://schemas.openxmlformats.org/drawingml/2006/main" r:embed="Rd02d69e7b5b4421a">
+          <a:blip xmlns:r="http://schemas.openxmlformats.org/officeDocument/2006/relationships" xmlns:a="http://schemas.openxmlformats.org/drawingml/2006/main" r:embed="R42f9aa79cc474d84">
             <a:alphaModFix amt="28000"/>
           </a:blip>
           <a:stretch xmlns:a="http://schemas.openxmlformats.org/drawingml/2006/main"/>
@@ -3982,17 +3982,17 @@
   </p:cSld>
   <p:clrMap bg1="lt1" tx1="dk1" bg2="lt2" tx2="dk2" accent1="accent1" accent2="accent2" accent3="accent3" accent4="accent4" accent5="accent5" accent6="accent6" hlink="hlink" folHlink="folHlink"/>
   <p:sldLayoutIdLst>
-    <p:sldLayoutId xmlns:r="http://schemas.openxmlformats.org/officeDocument/2006/relationships" id="2147483649" r:id="R769c39d7cad6402a"/>
-    <p:sldLayoutId xmlns:r="http://schemas.openxmlformats.org/officeDocument/2006/relationships" id="2147483650" r:id="R93c8942cfe64415b"/>
-    <p:sldLayoutId xmlns:r="http://schemas.openxmlformats.org/officeDocument/2006/relationships" id="2147483651" r:id="R52df124207c0433f"/>
-    <p:sldLayoutId xmlns:r="http://schemas.openxmlformats.org/officeDocument/2006/relationships" id="2147483652" r:id="R5d1bf95330164a35"/>
-    <p:sldLayoutId xmlns:r="http://schemas.openxmlformats.org/officeDocument/2006/relationships" id="2147483653" r:id="Rf989f911fb1b408b"/>
-    <p:sldLayoutId xmlns:r="http://schemas.openxmlformats.org/officeDocument/2006/relationships" id="2147483654" r:id="R3dadd0296adc4b00"/>
-    <p:sldLayoutId xmlns:r="http://schemas.openxmlformats.org/officeDocument/2006/relationships" id="2147483655" r:id="Rc149dc3b90dc4977"/>
-    <p:sldLayoutId xmlns:r="http://schemas.openxmlformats.org/officeDocument/2006/relationships" id="2147483656" r:id="R899b7716fa3f4ac9"/>
-    <p:sldLayoutId xmlns:r="http://schemas.openxmlformats.org/officeDocument/2006/relationships" id="2147483657" r:id="R36a3609c18664d98"/>
-    <p:sldLayoutId xmlns:r="http://schemas.openxmlformats.org/officeDocument/2006/relationships" id="2147483658" r:id="Rf027d6339d50413a"/>
-    <p:sldLayoutId xmlns:r="http://schemas.openxmlformats.org/officeDocument/2006/relationships" id="2147483659" r:id="R82490bf08a014632"/>
+    <p:sldLayoutId xmlns:r="http://schemas.openxmlformats.org/officeDocument/2006/relationships" id="2147483649" r:id="Rc696308ec3574b91"/>
+    <p:sldLayoutId xmlns:r="http://schemas.openxmlformats.org/officeDocument/2006/relationships" id="2147483650" r:id="Rea04c539782c4e05"/>
+    <p:sldLayoutId xmlns:r="http://schemas.openxmlformats.org/officeDocument/2006/relationships" id="2147483651" r:id="Rec0d0497982b4f66"/>
+    <p:sldLayoutId xmlns:r="http://schemas.openxmlformats.org/officeDocument/2006/relationships" id="2147483652" r:id="R2060c9213e354a3d"/>
+    <p:sldLayoutId xmlns:r="http://schemas.openxmlformats.org/officeDocument/2006/relationships" id="2147483653" r:id="R7bdba952efee4973"/>
+    <p:sldLayoutId xmlns:r="http://schemas.openxmlformats.org/officeDocument/2006/relationships" id="2147483654" r:id="R9a128bca74c948f7"/>
+    <p:sldLayoutId xmlns:r="http://schemas.openxmlformats.org/officeDocument/2006/relationships" id="2147483655" r:id="Raf9254f953484359"/>
+    <p:sldLayoutId xmlns:r="http://schemas.openxmlformats.org/officeDocument/2006/relationships" id="2147483656" r:id="R82266c982e954c97"/>
+    <p:sldLayoutId xmlns:r="http://schemas.openxmlformats.org/officeDocument/2006/relationships" id="2147483657" r:id="R06b7910bd8d344de"/>
+    <p:sldLayoutId xmlns:r="http://schemas.openxmlformats.org/officeDocument/2006/relationships" id="2147483658" r:id="Rce250cdf5d8f4300"/>
+    <p:sldLayoutId xmlns:r="http://schemas.openxmlformats.org/officeDocument/2006/relationships" id="2147483659" r:id="R5fdaccd1d2e44e51"/>
   </p:sldLayoutIdLst>
   <p:hf hdr="0" ftr="0" dt="0"/>
   <p:txStyles>

</xml_diff>